<commit_message>
Update DeepSeek harness setup tutorial in Week 0.
Co-authored-by: Cursor <cursoragent@cursor.com>
</commit_message>
<xml_diff>
--- a/Week 0/LLM setup/安装deepseek harness教程.pptx
+++ b/Week 0/LLM setup/安装deepseek harness教程.pptx
@@ -5,16 +5,17 @@
     <p:sldMasterId id="2147483648" r:id="rId1"/>
   </p:sldMasterIdLst>
   <p:sldIdLst>
-    <p:sldId id="256" r:id="rId3"/>
-    <p:sldId id="266" r:id="rId4"/>
-    <p:sldId id="257" r:id="rId5"/>
-    <p:sldId id="258" r:id="rId6"/>
-    <p:sldId id="269" r:id="rId7"/>
-    <p:sldId id="270" r:id="rId8"/>
-    <p:sldId id="268" r:id="rId9"/>
-    <p:sldId id="259" r:id="rId10"/>
-    <p:sldId id="264" r:id="rId11"/>
-    <p:sldId id="260" r:id="rId12"/>
+    <p:sldId id="256" r:id="rId2"/>
+    <p:sldId id="266" r:id="rId3"/>
+    <p:sldId id="257" r:id="rId4"/>
+    <p:sldId id="258" r:id="rId5"/>
+    <p:sldId id="269" r:id="rId6"/>
+    <p:sldId id="270" r:id="rId7"/>
+    <p:sldId id="268" r:id="rId8"/>
+    <p:sldId id="259" r:id="rId9"/>
+    <p:sldId id="264" r:id="rId10"/>
+    <p:sldId id="260" r:id="rId11"/>
+    <p:sldId id="272" r:id="rId12"/>
     <p:sldId id="271" r:id="rId13"/>
   </p:sldIdLst>
   <p:sldSz cx="12192000" cy="6858000"/>
@@ -129,6 +130,9 @@
         </p15:guide>
       </p15:sldGuideLst>
     </p:ext>
+    <p:ext uri="{2D200454-40CA-4A62-9FC3-DE9A4176ACB9}">
+      <p15:notesGuideLst xmlns:p15="http://schemas.microsoft.com/office/powerpoint/2012/main"/>
+    </p:ext>
   </p:extLst>
 </p:presentation>
 </file>
@@ -159,7 +163,7 @@
           <p:nvPr>
             <p:ph type="ctrTitle"/>
             <p:custDataLst>
-              <p:tags r:id="rId2"/>
+              <p:tags r:id="rId1"/>
             </p:custDataLst>
           </p:nvPr>
         </p:nvSpPr>
@@ -183,7 +187,6 @@
               <a:rPr lang="zh-CN" altLang="en-US" dirty="0"/>
               <a:t>单击此处编辑母版标题样式</a:t>
             </a:r>
-            <a:endParaRPr lang="zh-CN" altLang="en-US" dirty="0"/>
           </a:p>
         </p:txBody>
       </p:sp>
@@ -196,7 +199,7 @@
           <p:nvPr>
             <p:ph type="subTitle" idx="1"/>
             <p:custDataLst>
-              <p:tags r:id="rId3"/>
+              <p:tags r:id="rId2"/>
             </p:custDataLst>
           </p:nvPr>
         </p:nvSpPr>
@@ -256,7 +259,6 @@
               <a:rPr lang="zh-CN" altLang="en-US" dirty="0"/>
               <a:t>单击此处编辑母版副标题样式</a:t>
             </a:r>
-            <a:endParaRPr lang="zh-CN" altLang="en-US" dirty="0"/>
           </a:p>
         </p:txBody>
       </p:sp>
@@ -269,7 +271,7 @@
           <p:nvPr>
             <p:ph type="dt" sz="half" idx="10"/>
             <p:custDataLst>
-              <p:tags r:id="rId4"/>
+              <p:tags r:id="rId3"/>
             </p:custDataLst>
           </p:nvPr>
         </p:nvSpPr>
@@ -280,6 +282,7 @@
           <a:p>
             <a:fld id="{760FBDFE-C587-4B4C-A407-44438C67B59E}" type="datetimeFigureOut">
               <a:rPr lang="zh-CN" altLang="en-US" smtClean="0"/>
+              <a:t>2026/8/25</a:t>
             </a:fld>
             <a:endParaRPr lang="zh-CN" altLang="en-US"/>
           </a:p>
@@ -294,7 +297,7 @@
           <p:nvPr>
             <p:ph type="ftr" sz="quarter" idx="11"/>
             <p:custDataLst>
-              <p:tags r:id="rId5"/>
+              <p:tags r:id="rId4"/>
             </p:custDataLst>
           </p:nvPr>
         </p:nvSpPr>
@@ -316,7 +319,7 @@
           <p:nvPr>
             <p:ph type="sldNum" sz="quarter" idx="12"/>
             <p:custDataLst>
-              <p:tags r:id="rId6"/>
+              <p:tags r:id="rId5"/>
             </p:custDataLst>
           </p:nvPr>
         </p:nvSpPr>
@@ -327,6 +330,7 @@
           <a:p>
             <a:fld id="{49AE70B2-8BF9-45C0-BB95-33D1B9D3A854}" type="slidenum">
               <a:rPr lang="zh-CN" altLang="en-US" smtClean="0"/>
+              <a:t>‹#›</a:t>
             </a:fld>
             <a:endParaRPr lang="zh-CN" altLang="en-US" dirty="0"/>
           </a:p>
@@ -366,7 +370,7 @@
           <p:nvPr>
             <p:ph type="dt" sz="half" idx="10"/>
             <p:custDataLst>
-              <p:tags r:id="rId2"/>
+              <p:tags r:id="rId1"/>
             </p:custDataLst>
           </p:nvPr>
         </p:nvSpPr>
@@ -377,6 +381,7 @@
           <a:p>
             <a:fld id="{760FBDFE-C587-4B4C-A407-44438C67B59E}" type="datetimeFigureOut">
               <a:rPr lang="zh-CN" altLang="en-US" smtClean="0"/>
+              <a:t>2026/8/25</a:t>
             </a:fld>
             <a:endParaRPr lang="zh-CN" altLang="en-US"/>
           </a:p>
@@ -391,7 +396,7 @@
           <p:nvPr>
             <p:ph type="ftr" sz="quarter" idx="11"/>
             <p:custDataLst>
-              <p:tags r:id="rId3"/>
+              <p:tags r:id="rId2"/>
             </p:custDataLst>
           </p:nvPr>
         </p:nvSpPr>
@@ -413,7 +418,7 @@
           <p:nvPr>
             <p:ph type="sldNum" sz="quarter" idx="12"/>
             <p:custDataLst>
-              <p:tags r:id="rId4"/>
+              <p:tags r:id="rId3"/>
             </p:custDataLst>
           </p:nvPr>
         </p:nvSpPr>
@@ -424,6 +429,7 @@
           <a:p>
             <a:fld id="{49AE70B2-8BF9-45C0-BB95-33D1B9D3A854}" type="slidenum">
               <a:rPr lang="zh-CN" altLang="en-US" smtClean="0"/>
+              <a:t>‹#›</a:t>
             </a:fld>
             <a:endParaRPr lang="zh-CN" altLang="en-US"/>
           </a:p>
@@ -438,7 +444,7 @@
           <p:nvPr>
             <p:ph sz="quarter" idx="13"/>
             <p:custDataLst>
-              <p:tags r:id="rId5"/>
+              <p:tags r:id="rId4"/>
             </p:custDataLst>
           </p:nvPr>
         </p:nvSpPr>
@@ -457,7 +463,6 @@
               <a:rPr lang="zh-CN" altLang="en-US" dirty="0"/>
               <a:t>单击此处编辑母版文本样式</a:t>
             </a:r>
-            <a:endParaRPr lang="zh-CN" altLang="en-US" dirty="0"/>
           </a:p>
           <a:p>
             <a:pPr lvl="1"/>
@@ -465,7 +470,6 @@
               <a:rPr lang="zh-CN" altLang="en-US" dirty="0"/>
               <a:t>第二级</a:t>
             </a:r>
-            <a:endParaRPr lang="zh-CN" altLang="en-US" dirty="0"/>
           </a:p>
           <a:p>
             <a:pPr lvl="2"/>
@@ -473,7 +477,6 @@
               <a:rPr lang="zh-CN" altLang="en-US" dirty="0"/>
               <a:t>第三级</a:t>
             </a:r>
-            <a:endParaRPr lang="zh-CN" altLang="en-US" dirty="0"/>
           </a:p>
           <a:p>
             <a:pPr lvl="3"/>
@@ -481,7 +484,6 @@
               <a:rPr lang="zh-CN" altLang="en-US" dirty="0"/>
               <a:t>第四级</a:t>
             </a:r>
-            <a:endParaRPr lang="zh-CN" altLang="en-US" dirty="0"/>
           </a:p>
           <a:p>
             <a:pPr lvl="4"/>
@@ -489,7 +491,6 @@
               <a:rPr lang="zh-CN" altLang="en-US" dirty="0"/>
               <a:t>第五级</a:t>
             </a:r>
-            <a:endParaRPr lang="zh-CN" altLang="en-US" dirty="0"/>
           </a:p>
         </p:txBody>
       </p:sp>
@@ -527,7 +528,7 @@
           <p:nvPr>
             <p:ph type="dt" sz="half" idx="10"/>
             <p:custDataLst>
-              <p:tags r:id="rId2"/>
+              <p:tags r:id="rId1"/>
             </p:custDataLst>
           </p:nvPr>
         </p:nvSpPr>
@@ -538,6 +539,7 @@
           <a:p>
             <a:fld id="{760FBDFE-C587-4B4C-A407-44438C67B59E}" type="datetimeFigureOut">
               <a:rPr lang="zh-CN" altLang="en-US" smtClean="0"/>
+              <a:t>2026/8/25</a:t>
             </a:fld>
             <a:endParaRPr lang="zh-CN" altLang="en-US"/>
           </a:p>
@@ -552,7 +554,7 @@
           <p:nvPr>
             <p:ph type="ftr" sz="quarter" idx="11"/>
             <p:custDataLst>
-              <p:tags r:id="rId3"/>
+              <p:tags r:id="rId2"/>
             </p:custDataLst>
           </p:nvPr>
         </p:nvSpPr>
@@ -574,7 +576,7 @@
           <p:nvPr>
             <p:ph type="sldNum" sz="quarter" idx="12"/>
             <p:custDataLst>
-              <p:tags r:id="rId4"/>
+              <p:tags r:id="rId3"/>
             </p:custDataLst>
           </p:nvPr>
         </p:nvSpPr>
@@ -585,6 +587,7 @@
           <a:p>
             <a:fld id="{49AE70B2-8BF9-45C0-BB95-33D1B9D3A854}" type="slidenum">
               <a:rPr lang="zh-CN" altLang="en-US" smtClean="0"/>
+              <a:t>‹#›</a:t>
             </a:fld>
             <a:endParaRPr lang="zh-CN" altLang="en-US"/>
           </a:p>
@@ -599,7 +602,7 @@
           <p:nvPr>
             <p:ph type="title" hasCustomPrompt="1"/>
             <p:custDataLst>
-              <p:tags r:id="rId5"/>
+              <p:tags r:id="rId4"/>
             </p:custDataLst>
           </p:nvPr>
         </p:nvSpPr>
@@ -621,10 +624,9 @@
           <a:p>
             <a:pPr lvl="0"/>
             <a:r>
-              <a:rPr lang="zh-CN" altLang="en-US" smtClean="0"/>
+              <a:rPr lang="zh-CN" altLang="en-US"/>
               <a:t>单击此处编辑标题</a:t>
             </a:r>
-            <a:endParaRPr lang="zh-CN" altLang="en-US"/>
           </a:p>
         </p:txBody>
       </p:sp>
@@ -637,7 +639,7 @@
           <p:nvPr>
             <p:ph type="body" sz="quarter" idx="13"/>
             <p:custDataLst>
-              <p:tags r:id="rId6"/>
+              <p:tags r:id="rId5"/>
             </p:custDataLst>
           </p:nvPr>
         </p:nvSpPr>
@@ -666,7 +668,6 @@
               <a:rPr lang="zh-CN" altLang="en-US" dirty="0"/>
               <a:t>单击此处编辑母版文本样式</a:t>
             </a:r>
-            <a:endParaRPr lang="zh-CN" altLang="en-US" dirty="0"/>
           </a:p>
         </p:txBody>
       </p:sp>
@@ -704,7 +705,7 @@
           <p:nvPr>
             <p:ph type="title"/>
             <p:custDataLst>
-              <p:tags r:id="rId2"/>
+              <p:tags r:id="rId1"/>
             </p:custDataLst>
           </p:nvPr>
         </p:nvSpPr>
@@ -722,10 +723,9 @@
           <a:p>
             <a:pPr lvl="0"/>
             <a:r>
-              <a:rPr lang="zh-CN" altLang="en-US" smtClean="0"/>
+              <a:rPr lang="zh-CN" altLang="en-US"/>
               <a:t>单击此处编辑母版标题样式</a:t>
             </a:r>
-            <a:endParaRPr lang="zh-CN" altLang="en-US"/>
           </a:p>
         </p:txBody>
       </p:sp>
@@ -738,7 +738,7 @@
           <p:nvPr>
             <p:ph idx="1"/>
             <p:custDataLst>
-              <p:tags r:id="rId3"/>
+              <p:tags r:id="rId2"/>
             </p:custDataLst>
           </p:nvPr>
         </p:nvSpPr>
@@ -756,42 +756,37 @@
           <a:p>
             <a:pPr lvl="0"/>
             <a:r>
-              <a:rPr lang="zh-CN" altLang="en-US" smtClean="0"/>
+              <a:rPr lang="zh-CN" altLang="en-US"/>
               <a:t>单击此处编辑母版文本样式</a:t>
             </a:r>
-            <a:endParaRPr lang="zh-CN" altLang="en-US" smtClean="0"/>
           </a:p>
           <a:p>
             <a:pPr lvl="1"/>
             <a:r>
-              <a:rPr lang="zh-CN" altLang="en-US" smtClean="0"/>
+              <a:rPr lang="zh-CN" altLang="en-US"/>
               <a:t>第二级</a:t>
             </a:r>
-            <a:endParaRPr lang="zh-CN" altLang="en-US" smtClean="0"/>
           </a:p>
           <a:p>
             <a:pPr lvl="2"/>
             <a:r>
-              <a:rPr lang="zh-CN" altLang="en-US" smtClean="0"/>
+              <a:rPr lang="zh-CN" altLang="en-US"/>
               <a:t>第三级</a:t>
             </a:r>
-            <a:endParaRPr lang="zh-CN" altLang="en-US" smtClean="0"/>
           </a:p>
           <a:p>
             <a:pPr lvl="3"/>
             <a:r>
-              <a:rPr lang="zh-CN" altLang="en-US" smtClean="0"/>
+              <a:rPr lang="zh-CN" altLang="en-US"/>
               <a:t>第四级</a:t>
             </a:r>
-            <a:endParaRPr lang="zh-CN" altLang="en-US" smtClean="0"/>
           </a:p>
           <a:p>
             <a:pPr lvl="4"/>
             <a:r>
-              <a:rPr lang="zh-CN" altLang="en-US" smtClean="0"/>
+              <a:rPr lang="zh-CN" altLang="en-US"/>
               <a:t>第五级</a:t>
             </a:r>
-            <a:endParaRPr lang="zh-CN" altLang="en-US"/>
           </a:p>
         </p:txBody>
       </p:sp>
@@ -804,7 +799,7 @@
           <p:nvPr>
             <p:ph type="dt" sz="half" idx="10"/>
             <p:custDataLst>
-              <p:tags r:id="rId4"/>
+              <p:tags r:id="rId3"/>
             </p:custDataLst>
           </p:nvPr>
         </p:nvSpPr>
@@ -815,6 +810,7 @@
           <a:p>
             <a:fld id="{760FBDFE-C587-4B4C-A407-44438C67B59E}" type="datetimeFigureOut">
               <a:rPr lang="zh-CN" altLang="en-US" smtClean="0"/>
+              <a:t>2026/8/25</a:t>
             </a:fld>
             <a:endParaRPr lang="zh-CN" altLang="en-US"/>
           </a:p>
@@ -829,7 +825,7 @@
           <p:nvPr>
             <p:ph type="ftr" sz="quarter" idx="11"/>
             <p:custDataLst>
-              <p:tags r:id="rId5"/>
+              <p:tags r:id="rId4"/>
             </p:custDataLst>
           </p:nvPr>
         </p:nvSpPr>
@@ -851,7 +847,7 @@
           <p:nvPr>
             <p:ph type="sldNum" sz="quarter" idx="12"/>
             <p:custDataLst>
-              <p:tags r:id="rId6"/>
+              <p:tags r:id="rId5"/>
             </p:custDataLst>
           </p:nvPr>
         </p:nvSpPr>
@@ -862,6 +858,7 @@
           <a:p>
             <a:fld id="{49AE70B2-8BF9-45C0-BB95-33D1B9D3A854}" type="slidenum">
               <a:rPr lang="zh-CN" altLang="en-US" smtClean="0"/>
+              <a:t>‹#›</a:t>
             </a:fld>
             <a:endParaRPr lang="zh-CN" altLang="en-US"/>
           </a:p>
@@ -901,7 +898,7 @@
           <p:nvPr>
             <p:ph type="title" hasCustomPrompt="1"/>
             <p:custDataLst>
-              <p:tags r:id="rId2"/>
+              <p:tags r:id="rId1"/>
             </p:custDataLst>
           </p:nvPr>
         </p:nvSpPr>
@@ -925,7 +922,6 @@
               <a:rPr lang="zh-CN" altLang="en-US" dirty="0"/>
               <a:t>单击此处编辑标题</a:t>
             </a:r>
-            <a:endParaRPr lang="zh-CN" altLang="en-US" dirty="0"/>
           </a:p>
         </p:txBody>
       </p:sp>
@@ -938,7 +934,7 @@
           <p:nvPr>
             <p:ph type="body" idx="1" hasCustomPrompt="1"/>
             <p:custDataLst>
-              <p:tags r:id="rId3"/>
+              <p:tags r:id="rId2"/>
             </p:custDataLst>
           </p:nvPr>
         </p:nvSpPr>
@@ -1051,7 +1047,6 @@
               <a:rPr lang="zh-CN" altLang="en-US" dirty="0"/>
               <a:t>单击此处编辑文本</a:t>
             </a:r>
-            <a:endParaRPr lang="zh-CN" altLang="en-US" dirty="0"/>
           </a:p>
         </p:txBody>
       </p:sp>
@@ -1064,7 +1059,7 @@
           <p:nvPr>
             <p:ph type="dt" sz="half" idx="10"/>
             <p:custDataLst>
-              <p:tags r:id="rId4"/>
+              <p:tags r:id="rId3"/>
             </p:custDataLst>
           </p:nvPr>
         </p:nvSpPr>
@@ -1075,6 +1070,7 @@
           <a:p>
             <a:fld id="{760FBDFE-C587-4B4C-A407-44438C67B59E}" type="datetimeFigureOut">
               <a:rPr lang="zh-CN" altLang="en-US" smtClean="0"/>
+              <a:t>2026/8/25</a:t>
             </a:fld>
             <a:endParaRPr lang="zh-CN" altLang="en-US"/>
           </a:p>
@@ -1089,7 +1085,7 @@
           <p:nvPr>
             <p:ph type="ftr" sz="quarter" idx="11"/>
             <p:custDataLst>
-              <p:tags r:id="rId5"/>
+              <p:tags r:id="rId4"/>
             </p:custDataLst>
           </p:nvPr>
         </p:nvSpPr>
@@ -1111,7 +1107,7 @@
           <p:nvPr>
             <p:ph type="sldNum" sz="quarter" idx="12"/>
             <p:custDataLst>
-              <p:tags r:id="rId6"/>
+              <p:tags r:id="rId5"/>
             </p:custDataLst>
           </p:nvPr>
         </p:nvSpPr>
@@ -1122,6 +1118,7 @@
           <a:p>
             <a:fld id="{49AE70B2-8BF9-45C0-BB95-33D1B9D3A854}" type="slidenum">
               <a:rPr lang="zh-CN" altLang="en-US" smtClean="0"/>
+              <a:t>‹#›</a:t>
             </a:fld>
             <a:endParaRPr lang="zh-CN" altLang="en-US"/>
           </a:p>
@@ -1161,7 +1158,7 @@
           <p:nvPr>
             <p:ph type="title"/>
             <p:custDataLst>
-              <p:tags r:id="rId2"/>
+              <p:tags r:id="rId1"/>
             </p:custDataLst>
           </p:nvPr>
         </p:nvSpPr>
@@ -1179,10 +1176,9 @@
           <a:p>
             <a:pPr lvl="0"/>
             <a:r>
-              <a:rPr lang="zh-CN" altLang="en-US" smtClean="0"/>
+              <a:rPr lang="zh-CN" altLang="en-US"/>
               <a:t>单击此处编辑母版标题样式</a:t>
             </a:r>
-            <a:endParaRPr lang="zh-CN" altLang="en-US"/>
           </a:p>
         </p:txBody>
       </p:sp>
@@ -1195,7 +1191,7 @@
           <p:nvPr>
             <p:ph sz="half" idx="1"/>
             <p:custDataLst>
-              <p:tags r:id="rId3"/>
+              <p:tags r:id="rId2"/>
             </p:custDataLst>
           </p:nvPr>
         </p:nvSpPr>
@@ -1213,42 +1209,37 @@
           <a:p>
             <a:pPr lvl="0"/>
             <a:r>
-              <a:rPr lang="zh-CN" altLang="en-US" smtClean="0"/>
+              <a:rPr lang="zh-CN" altLang="en-US"/>
               <a:t>单击此处编辑母版文本样式</a:t>
             </a:r>
-            <a:endParaRPr lang="zh-CN" altLang="en-US" smtClean="0"/>
           </a:p>
           <a:p>
             <a:pPr lvl="1"/>
             <a:r>
-              <a:rPr lang="zh-CN" altLang="en-US" smtClean="0"/>
+              <a:rPr lang="zh-CN" altLang="en-US"/>
               <a:t>第二级</a:t>
             </a:r>
-            <a:endParaRPr lang="zh-CN" altLang="en-US" smtClean="0"/>
           </a:p>
           <a:p>
             <a:pPr lvl="2"/>
             <a:r>
-              <a:rPr lang="zh-CN" altLang="en-US" smtClean="0"/>
+              <a:rPr lang="zh-CN" altLang="en-US"/>
               <a:t>第三级</a:t>
             </a:r>
-            <a:endParaRPr lang="zh-CN" altLang="en-US" smtClean="0"/>
           </a:p>
           <a:p>
             <a:pPr lvl="3"/>
             <a:r>
-              <a:rPr lang="zh-CN" altLang="en-US" smtClean="0"/>
+              <a:rPr lang="zh-CN" altLang="en-US"/>
               <a:t>第四级</a:t>
             </a:r>
-            <a:endParaRPr lang="zh-CN" altLang="en-US" smtClean="0"/>
           </a:p>
           <a:p>
             <a:pPr lvl="4"/>
             <a:r>
-              <a:rPr lang="zh-CN" altLang="en-US" smtClean="0"/>
+              <a:rPr lang="zh-CN" altLang="en-US"/>
               <a:t>第五级</a:t>
             </a:r>
-            <a:endParaRPr lang="zh-CN" altLang="en-US"/>
           </a:p>
         </p:txBody>
       </p:sp>
@@ -1261,7 +1252,7 @@
           <p:nvPr>
             <p:ph sz="half" idx="2"/>
             <p:custDataLst>
-              <p:tags r:id="rId4"/>
+              <p:tags r:id="rId3"/>
             </p:custDataLst>
           </p:nvPr>
         </p:nvSpPr>
@@ -1282,7 +1273,6 @@
               <a:rPr lang="zh-CN" altLang="en-US" dirty="0"/>
               <a:t>单击此处编辑母版文本样式</a:t>
             </a:r>
-            <a:endParaRPr lang="zh-CN" altLang="en-US" dirty="0"/>
           </a:p>
           <a:p>
             <a:pPr lvl="1"/>
@@ -1290,7 +1280,6 @@
               <a:rPr lang="zh-CN" altLang="en-US" dirty="0"/>
               <a:t>第二级</a:t>
             </a:r>
-            <a:endParaRPr lang="zh-CN" altLang="en-US" dirty="0"/>
           </a:p>
           <a:p>
             <a:pPr lvl="2"/>
@@ -1298,7 +1287,6 @@
               <a:rPr lang="zh-CN" altLang="en-US" dirty="0"/>
               <a:t>第三级</a:t>
             </a:r>
-            <a:endParaRPr lang="zh-CN" altLang="en-US" dirty="0"/>
           </a:p>
           <a:p>
             <a:pPr lvl="3"/>
@@ -1306,7 +1294,6 @@
               <a:rPr lang="zh-CN" altLang="en-US" dirty="0"/>
               <a:t>第四级</a:t>
             </a:r>
-            <a:endParaRPr lang="zh-CN" altLang="en-US" dirty="0"/>
           </a:p>
           <a:p>
             <a:pPr lvl="4"/>
@@ -1314,7 +1301,6 @@
               <a:rPr lang="zh-CN" altLang="en-US" dirty="0"/>
               <a:t>第五级</a:t>
             </a:r>
-            <a:endParaRPr lang="zh-CN" altLang="en-US" dirty="0"/>
           </a:p>
         </p:txBody>
       </p:sp>
@@ -1327,7 +1313,7 @@
           <p:nvPr>
             <p:ph type="dt" sz="half" idx="10"/>
             <p:custDataLst>
-              <p:tags r:id="rId5"/>
+              <p:tags r:id="rId4"/>
             </p:custDataLst>
           </p:nvPr>
         </p:nvSpPr>
@@ -1338,6 +1324,7 @@
           <a:p>
             <a:fld id="{760FBDFE-C587-4B4C-A407-44438C67B59E}" type="datetimeFigureOut">
               <a:rPr lang="zh-CN" altLang="en-US" smtClean="0"/>
+              <a:t>2026/8/25</a:t>
             </a:fld>
             <a:endParaRPr lang="zh-CN" altLang="en-US"/>
           </a:p>
@@ -1352,7 +1339,7 @@
           <p:nvPr>
             <p:ph type="ftr" sz="quarter" idx="11"/>
             <p:custDataLst>
-              <p:tags r:id="rId6"/>
+              <p:tags r:id="rId5"/>
             </p:custDataLst>
           </p:nvPr>
         </p:nvSpPr>
@@ -1374,7 +1361,7 @@
           <p:nvPr>
             <p:ph type="sldNum" sz="quarter" idx="12"/>
             <p:custDataLst>
-              <p:tags r:id="rId7"/>
+              <p:tags r:id="rId6"/>
             </p:custDataLst>
           </p:nvPr>
         </p:nvSpPr>
@@ -1385,6 +1372,7 @@
           <a:p>
             <a:fld id="{49AE70B2-8BF9-45C0-BB95-33D1B9D3A854}" type="slidenum">
               <a:rPr lang="zh-CN" altLang="en-US" smtClean="0"/>
+              <a:t>‹#›</a:t>
             </a:fld>
             <a:endParaRPr lang="zh-CN" altLang="en-US"/>
           </a:p>
@@ -1424,7 +1412,7 @@
           <p:nvPr>
             <p:ph type="title"/>
             <p:custDataLst>
-              <p:tags r:id="rId2"/>
+              <p:tags r:id="rId1"/>
             </p:custDataLst>
           </p:nvPr>
         </p:nvSpPr>
@@ -1442,10 +1430,9 @@
           <a:p>
             <a:pPr lvl="0"/>
             <a:r>
-              <a:rPr lang="zh-CN" altLang="en-US" smtClean="0"/>
+              <a:rPr lang="zh-CN" altLang="en-US"/>
               <a:t>单击此处编辑母版标题样式</a:t>
             </a:r>
-            <a:endParaRPr lang="zh-CN" altLang="en-US"/>
           </a:p>
         </p:txBody>
       </p:sp>
@@ -1458,7 +1445,7 @@
           <p:nvPr>
             <p:ph type="body" idx="1" hasCustomPrompt="1"/>
             <p:custDataLst>
-              <p:tags r:id="rId3"/>
+              <p:tags r:id="rId2"/>
             </p:custDataLst>
           </p:nvPr>
         </p:nvSpPr>
@@ -1526,7 +1513,6 @@
               <a:rPr lang="zh-CN" altLang="en-US" dirty="0"/>
               <a:t>单击此处编辑文本</a:t>
             </a:r>
-            <a:endParaRPr lang="zh-CN" altLang="en-US" dirty="0"/>
           </a:p>
         </p:txBody>
       </p:sp>
@@ -1539,7 +1525,7 @@
           <p:nvPr>
             <p:ph sz="half" idx="2"/>
             <p:custDataLst>
-              <p:tags r:id="rId4"/>
+              <p:tags r:id="rId3"/>
             </p:custDataLst>
           </p:nvPr>
         </p:nvSpPr>
@@ -1557,42 +1543,37 @@
           <a:p>
             <a:pPr lvl="0"/>
             <a:r>
-              <a:rPr lang="zh-CN" altLang="en-US" smtClean="0"/>
+              <a:rPr lang="zh-CN" altLang="en-US"/>
               <a:t>单击此处编辑母版文本样式</a:t>
             </a:r>
-            <a:endParaRPr lang="zh-CN" altLang="en-US" smtClean="0"/>
           </a:p>
           <a:p>
             <a:pPr lvl="1"/>
             <a:r>
-              <a:rPr lang="zh-CN" altLang="en-US" smtClean="0"/>
+              <a:rPr lang="zh-CN" altLang="en-US"/>
               <a:t>第二级</a:t>
             </a:r>
-            <a:endParaRPr lang="zh-CN" altLang="en-US" smtClean="0"/>
           </a:p>
           <a:p>
             <a:pPr lvl="2"/>
             <a:r>
-              <a:rPr lang="zh-CN" altLang="en-US" smtClean="0"/>
+              <a:rPr lang="zh-CN" altLang="en-US"/>
               <a:t>第三级</a:t>
             </a:r>
-            <a:endParaRPr lang="zh-CN" altLang="en-US" smtClean="0"/>
           </a:p>
           <a:p>
             <a:pPr lvl="3"/>
             <a:r>
-              <a:rPr lang="zh-CN" altLang="en-US" smtClean="0"/>
+              <a:rPr lang="zh-CN" altLang="en-US"/>
               <a:t>第四级</a:t>
             </a:r>
-            <a:endParaRPr lang="zh-CN" altLang="en-US" smtClean="0"/>
           </a:p>
           <a:p>
             <a:pPr lvl="4"/>
             <a:r>
-              <a:rPr lang="zh-CN" altLang="en-US" smtClean="0"/>
+              <a:rPr lang="zh-CN" altLang="en-US"/>
               <a:t>第五级</a:t>
             </a:r>
-            <a:endParaRPr lang="zh-CN" altLang="en-US"/>
           </a:p>
         </p:txBody>
       </p:sp>
@@ -1605,7 +1586,7 @@
           <p:nvPr>
             <p:ph type="body" sz="quarter" idx="3" hasCustomPrompt="1"/>
             <p:custDataLst>
-              <p:tags r:id="rId5"/>
+              <p:tags r:id="rId4"/>
             </p:custDataLst>
           </p:nvPr>
         </p:nvSpPr>
@@ -1670,10 +1651,9 @@
           <a:p>
             <a:pPr lvl="0"/>
             <a:r>
-              <a:rPr lang="zh-CN" altLang="en-US" smtClean="0"/>
+              <a:rPr lang="zh-CN" altLang="en-US"/>
               <a:t>单击此处编辑文本</a:t>
             </a:r>
-            <a:endParaRPr lang="zh-CN" altLang="en-US"/>
           </a:p>
         </p:txBody>
       </p:sp>
@@ -1686,7 +1666,7 @@
           <p:nvPr>
             <p:ph sz="quarter" idx="4"/>
             <p:custDataLst>
-              <p:tags r:id="rId6"/>
+              <p:tags r:id="rId5"/>
             </p:custDataLst>
           </p:nvPr>
         </p:nvSpPr>
@@ -1704,42 +1684,37 @@
           <a:p>
             <a:pPr lvl="0"/>
             <a:r>
-              <a:rPr lang="zh-CN" altLang="en-US" smtClean="0"/>
+              <a:rPr lang="zh-CN" altLang="en-US"/>
               <a:t>单击此处编辑母版文本样式</a:t>
             </a:r>
-            <a:endParaRPr lang="zh-CN" altLang="en-US" smtClean="0"/>
           </a:p>
           <a:p>
             <a:pPr lvl="1"/>
             <a:r>
-              <a:rPr lang="zh-CN" altLang="en-US" smtClean="0"/>
+              <a:rPr lang="zh-CN" altLang="en-US"/>
               <a:t>第二级</a:t>
             </a:r>
-            <a:endParaRPr lang="zh-CN" altLang="en-US" smtClean="0"/>
           </a:p>
           <a:p>
             <a:pPr lvl="2"/>
             <a:r>
-              <a:rPr lang="zh-CN" altLang="en-US" smtClean="0"/>
+              <a:rPr lang="zh-CN" altLang="en-US"/>
               <a:t>第三级</a:t>
             </a:r>
-            <a:endParaRPr lang="zh-CN" altLang="en-US" smtClean="0"/>
           </a:p>
           <a:p>
             <a:pPr lvl="3"/>
             <a:r>
-              <a:rPr lang="zh-CN" altLang="en-US" smtClean="0"/>
+              <a:rPr lang="zh-CN" altLang="en-US"/>
               <a:t>第四级</a:t>
             </a:r>
-            <a:endParaRPr lang="zh-CN" altLang="en-US" smtClean="0"/>
           </a:p>
           <a:p>
             <a:pPr lvl="4"/>
             <a:r>
-              <a:rPr lang="zh-CN" altLang="en-US" smtClean="0"/>
+              <a:rPr lang="zh-CN" altLang="en-US"/>
               <a:t>第五级</a:t>
             </a:r>
-            <a:endParaRPr lang="zh-CN" altLang="en-US"/>
           </a:p>
         </p:txBody>
       </p:sp>
@@ -1752,7 +1727,7 @@
           <p:nvPr>
             <p:ph type="dt" sz="half" idx="10"/>
             <p:custDataLst>
-              <p:tags r:id="rId7"/>
+              <p:tags r:id="rId6"/>
             </p:custDataLst>
           </p:nvPr>
         </p:nvSpPr>
@@ -1763,6 +1738,7 @@
           <a:p>
             <a:fld id="{760FBDFE-C587-4B4C-A407-44438C67B59E}" type="datetimeFigureOut">
               <a:rPr lang="zh-CN" altLang="en-US" smtClean="0"/>
+              <a:t>2026/8/25</a:t>
             </a:fld>
             <a:endParaRPr lang="zh-CN" altLang="en-US"/>
           </a:p>
@@ -1777,7 +1753,7 @@
           <p:nvPr>
             <p:ph type="ftr" sz="quarter" idx="11"/>
             <p:custDataLst>
-              <p:tags r:id="rId8"/>
+              <p:tags r:id="rId7"/>
             </p:custDataLst>
           </p:nvPr>
         </p:nvSpPr>
@@ -1799,7 +1775,7 @@
           <p:nvPr>
             <p:ph type="sldNum" sz="quarter" idx="12"/>
             <p:custDataLst>
-              <p:tags r:id="rId9"/>
+              <p:tags r:id="rId8"/>
             </p:custDataLst>
           </p:nvPr>
         </p:nvSpPr>
@@ -1810,6 +1786,7 @@
           <a:p>
             <a:fld id="{49AE70B2-8BF9-45C0-BB95-33D1B9D3A854}" type="slidenum">
               <a:rPr lang="zh-CN" altLang="en-US" smtClean="0"/>
+              <a:t>‹#›</a:t>
             </a:fld>
             <a:endParaRPr lang="zh-CN" altLang="en-US"/>
           </a:p>
@@ -1849,7 +1826,7 @@
           <p:nvPr>
             <p:ph type="title"/>
             <p:custDataLst>
-              <p:tags r:id="rId2"/>
+              <p:tags r:id="rId1"/>
             </p:custDataLst>
           </p:nvPr>
         </p:nvSpPr>
@@ -1867,10 +1844,9 @@
           <a:p>
             <a:pPr lvl="0"/>
             <a:r>
-              <a:rPr lang="zh-CN" altLang="en-US" smtClean="0"/>
+              <a:rPr lang="zh-CN" altLang="en-US"/>
               <a:t>单击此处编辑母版标题样式</a:t>
             </a:r>
-            <a:endParaRPr lang="zh-CN" altLang="en-US"/>
           </a:p>
         </p:txBody>
       </p:sp>
@@ -1883,7 +1859,7 @@
           <p:nvPr>
             <p:ph type="dt" sz="half" idx="10"/>
             <p:custDataLst>
-              <p:tags r:id="rId3"/>
+              <p:tags r:id="rId2"/>
             </p:custDataLst>
           </p:nvPr>
         </p:nvSpPr>
@@ -1894,6 +1870,7 @@
           <a:p>
             <a:fld id="{760FBDFE-C587-4B4C-A407-44438C67B59E}" type="datetimeFigureOut">
               <a:rPr lang="zh-CN" altLang="en-US" smtClean="0"/>
+              <a:t>2026/8/25</a:t>
             </a:fld>
             <a:endParaRPr lang="zh-CN" altLang="en-US"/>
           </a:p>
@@ -1908,7 +1885,7 @@
           <p:nvPr>
             <p:ph type="ftr" sz="quarter" idx="11"/>
             <p:custDataLst>
-              <p:tags r:id="rId4"/>
+              <p:tags r:id="rId3"/>
             </p:custDataLst>
           </p:nvPr>
         </p:nvSpPr>
@@ -1930,7 +1907,7 @@
           <p:nvPr>
             <p:ph type="sldNum" sz="quarter" idx="12"/>
             <p:custDataLst>
-              <p:tags r:id="rId5"/>
+              <p:tags r:id="rId4"/>
             </p:custDataLst>
           </p:nvPr>
         </p:nvSpPr>
@@ -1941,6 +1918,7 @@
           <a:p>
             <a:fld id="{49AE70B2-8BF9-45C0-BB95-33D1B9D3A854}" type="slidenum">
               <a:rPr lang="zh-CN" altLang="en-US" smtClean="0"/>
+              <a:t>‹#›</a:t>
             </a:fld>
             <a:endParaRPr lang="zh-CN" altLang="en-US"/>
           </a:p>
@@ -1980,7 +1958,7 @@
           <p:nvPr>
             <p:ph type="dt" sz="half" idx="10"/>
             <p:custDataLst>
-              <p:tags r:id="rId2"/>
+              <p:tags r:id="rId1"/>
             </p:custDataLst>
           </p:nvPr>
         </p:nvSpPr>
@@ -1991,6 +1969,7 @@
           <a:p>
             <a:fld id="{760FBDFE-C587-4B4C-A407-44438C67B59E}" type="datetimeFigureOut">
               <a:rPr lang="zh-CN" altLang="en-US" smtClean="0"/>
+              <a:t>2026/8/25</a:t>
             </a:fld>
             <a:endParaRPr lang="zh-CN" altLang="en-US"/>
           </a:p>
@@ -2005,7 +1984,7 @@
           <p:nvPr>
             <p:ph type="ftr" sz="quarter" idx="11"/>
             <p:custDataLst>
-              <p:tags r:id="rId3"/>
+              <p:tags r:id="rId2"/>
             </p:custDataLst>
           </p:nvPr>
         </p:nvSpPr>
@@ -2027,7 +2006,7 @@
           <p:nvPr>
             <p:ph type="sldNum" sz="quarter" idx="12"/>
             <p:custDataLst>
-              <p:tags r:id="rId4"/>
+              <p:tags r:id="rId3"/>
             </p:custDataLst>
           </p:nvPr>
         </p:nvSpPr>
@@ -2038,6 +2017,7 @@
           <a:p>
             <a:fld id="{49AE70B2-8BF9-45C0-BB95-33D1B9D3A854}" type="slidenum">
               <a:rPr lang="zh-CN" altLang="en-US" smtClean="0"/>
+              <a:t>‹#›</a:t>
             </a:fld>
             <a:endParaRPr lang="zh-CN" altLang="en-US"/>
           </a:p>
@@ -2077,7 +2057,7 @@
           <p:nvPr>
             <p:ph type="pic" idx="1"/>
             <p:custDataLst>
-              <p:tags r:id="rId2"/>
+              <p:tags r:id="rId1"/>
             </p:custDataLst>
           </p:nvPr>
         </p:nvSpPr>
@@ -2112,7 +2092,7 @@
           <p:nvPr>
             <p:ph type="body" sz="half" idx="2"/>
             <p:custDataLst>
-              <p:tags r:id="rId3"/>
+              <p:tags r:id="rId2"/>
             </p:custDataLst>
           </p:nvPr>
         </p:nvSpPr>
@@ -2135,10 +2115,9 @@
           <a:p>
             <a:pPr lvl="0"/>
             <a:r>
-              <a:rPr lang="zh-CN" altLang="en-US" smtClean="0"/>
+              <a:rPr lang="zh-CN" altLang="en-US"/>
               <a:t>单击此处编辑母版文本样式</a:t>
             </a:r>
-            <a:endParaRPr lang="zh-CN" altLang="en-US"/>
           </a:p>
         </p:txBody>
       </p:sp>
@@ -2151,7 +2130,7 @@
           <p:nvPr>
             <p:ph type="dt" sz="half" idx="10"/>
             <p:custDataLst>
-              <p:tags r:id="rId4"/>
+              <p:tags r:id="rId3"/>
             </p:custDataLst>
           </p:nvPr>
         </p:nvSpPr>
@@ -2162,6 +2141,7 @@
           <a:p>
             <a:fld id="{9EFD9D74-47D9-4702-A33C-335B63B48DBF}" type="datetimeFigureOut">
               <a:rPr lang="zh-CN" altLang="en-US" smtClean="0"/>
+              <a:t>2026/8/25</a:t>
             </a:fld>
             <a:endParaRPr lang="zh-CN" altLang="en-US" dirty="0"/>
           </a:p>
@@ -2176,7 +2156,7 @@
           <p:nvPr>
             <p:ph type="ftr" sz="quarter" idx="11"/>
             <p:custDataLst>
-              <p:tags r:id="rId5"/>
+              <p:tags r:id="rId4"/>
             </p:custDataLst>
           </p:nvPr>
         </p:nvSpPr>
@@ -2198,7 +2178,7 @@
           <p:nvPr>
             <p:ph type="sldNum" sz="quarter" idx="12"/>
             <p:custDataLst>
-              <p:tags r:id="rId6"/>
+              <p:tags r:id="rId5"/>
             </p:custDataLst>
           </p:nvPr>
         </p:nvSpPr>
@@ -2209,6 +2189,7 @@
           <a:p>
             <a:fld id="{FABC47A4-756D-490B-A52F-7D9E2C9FC05F}" type="slidenum">
               <a:rPr lang="zh-CN" altLang="en-US" smtClean="0"/>
+              <a:t>‹#›</a:t>
             </a:fld>
             <a:endParaRPr lang="zh-CN" altLang="en-US"/>
           </a:p>
@@ -2223,19 +2204,19 @@
           <p:nvPr>
             <p:ph type="title"/>
             <p:custDataLst>
-              <p:tags r:id="rId7"/>
+              <p:tags r:id="rId6"/>
             </p:custDataLst>
           </p:nvPr>
         </p:nvSpPr>
         <p:spPr/>
         <p:txBody>
           <a:bodyPr/>
+          <a:lstStyle/>
           <a:p>
             <a:r>
               <a:rPr lang="zh-CN" altLang="en-US"/>
               <a:t>单击此处编辑母版标题样式</a:t>
             </a:r>
-            <a:endParaRPr lang="zh-CN" altLang="en-US"/>
           </a:p>
         </p:txBody>
       </p:sp>
@@ -2273,7 +2254,7 @@
           <p:nvPr>
             <p:ph type="title" orient="vert" hasCustomPrompt="1"/>
             <p:custDataLst>
-              <p:tags r:id="rId2"/>
+              <p:tags r:id="rId1"/>
             </p:custDataLst>
           </p:nvPr>
         </p:nvSpPr>
@@ -2296,10 +2277,9 @@
           <a:p>
             <a:pPr lvl="0"/>
             <a:r>
-              <a:rPr lang="zh-CN" altLang="en-US" smtClean="0"/>
+              <a:rPr lang="zh-CN" altLang="en-US"/>
               <a:t>单击此处编辑标题</a:t>
             </a:r>
-            <a:endParaRPr lang="zh-CN" altLang="en-US"/>
           </a:p>
         </p:txBody>
       </p:sp>
@@ -2312,7 +2292,7 @@
           <p:nvPr>
             <p:ph type="body" orient="vert" idx="1"/>
             <p:custDataLst>
-              <p:tags r:id="rId3"/>
+              <p:tags r:id="rId2"/>
             </p:custDataLst>
           </p:nvPr>
         </p:nvSpPr>
@@ -2350,7 +2330,6 @@
               <a:rPr lang="zh-CN" altLang="en-US" dirty="0"/>
               <a:t>单击此处编辑母版文本样式</a:t>
             </a:r>
-            <a:endParaRPr lang="zh-CN" altLang="en-US" dirty="0"/>
           </a:p>
           <a:p>
             <a:pPr lvl="1"/>
@@ -2358,7 +2337,6 @@
               <a:rPr lang="zh-CN" altLang="en-US" dirty="0"/>
               <a:t>第二级</a:t>
             </a:r>
-            <a:endParaRPr lang="zh-CN" altLang="en-US" dirty="0"/>
           </a:p>
           <a:p>
             <a:pPr lvl="2"/>
@@ -2366,7 +2344,6 @@
               <a:rPr lang="zh-CN" altLang="en-US" dirty="0"/>
               <a:t>第三级</a:t>
             </a:r>
-            <a:endParaRPr lang="zh-CN" altLang="en-US" dirty="0"/>
           </a:p>
           <a:p>
             <a:pPr lvl="3"/>
@@ -2374,7 +2351,6 @@
               <a:rPr lang="zh-CN" altLang="en-US" dirty="0"/>
               <a:t>第四级</a:t>
             </a:r>
-            <a:endParaRPr lang="zh-CN" altLang="en-US" dirty="0"/>
           </a:p>
           <a:p>
             <a:pPr lvl="4"/>
@@ -2382,7 +2358,6 @@
               <a:rPr lang="zh-CN" altLang="en-US" dirty="0"/>
               <a:t>第五级</a:t>
             </a:r>
-            <a:endParaRPr lang="zh-CN" altLang="en-US" dirty="0"/>
           </a:p>
         </p:txBody>
       </p:sp>
@@ -2395,7 +2370,7 @@
           <p:nvPr>
             <p:ph type="dt" sz="half" idx="10"/>
             <p:custDataLst>
-              <p:tags r:id="rId4"/>
+              <p:tags r:id="rId3"/>
             </p:custDataLst>
           </p:nvPr>
         </p:nvSpPr>
@@ -2406,6 +2381,7 @@
           <a:p>
             <a:fld id="{760FBDFE-C587-4B4C-A407-44438C67B59E}" type="datetimeFigureOut">
               <a:rPr lang="zh-CN" altLang="en-US" smtClean="0"/>
+              <a:t>2026/8/25</a:t>
             </a:fld>
             <a:endParaRPr lang="zh-CN" altLang="en-US"/>
           </a:p>
@@ -2420,7 +2396,7 @@
           <p:nvPr>
             <p:ph type="ftr" sz="quarter" idx="11"/>
             <p:custDataLst>
-              <p:tags r:id="rId5"/>
+              <p:tags r:id="rId4"/>
             </p:custDataLst>
           </p:nvPr>
         </p:nvSpPr>
@@ -2442,7 +2418,7 @@
           <p:nvPr>
             <p:ph type="sldNum" sz="quarter" idx="12"/>
             <p:custDataLst>
-              <p:tags r:id="rId6"/>
+              <p:tags r:id="rId5"/>
             </p:custDataLst>
           </p:nvPr>
         </p:nvSpPr>
@@ -2453,6 +2429,7 @@
           <a:p>
             <a:fld id="{49AE70B2-8BF9-45C0-BB95-33D1B9D3A854}" type="slidenum">
               <a:rPr lang="zh-CN" altLang="en-US" smtClean="0"/>
+              <a:t>‹#›</a:t>
             </a:fld>
             <a:endParaRPr lang="zh-CN" altLang="en-US"/>
           </a:p>
@@ -2497,7 +2474,7 @@
           <p:nvPr>
             <p:ph type="title"/>
             <p:custDataLst>
-              <p:tags r:id="rId12"/>
+              <p:tags r:id="rId14"/>
             </p:custDataLst>
           </p:nvPr>
         </p:nvSpPr>
@@ -2520,7 +2497,6 @@
               <a:rPr lang="zh-CN" altLang="en-US" dirty="0"/>
               <a:t>单击此处编辑母版标题样式</a:t>
             </a:r>
-            <a:endParaRPr lang="zh-CN" altLang="en-US" dirty="0"/>
           </a:p>
         </p:txBody>
       </p:sp>
@@ -2533,7 +2509,7 @@
           <p:nvPr>
             <p:ph type="body" idx="1"/>
             <p:custDataLst>
-              <p:tags r:id="rId13"/>
+              <p:tags r:id="rId15"/>
             </p:custDataLst>
           </p:nvPr>
         </p:nvSpPr>
@@ -2557,7 +2533,6 @@
               <a:rPr lang="zh-CN" altLang="en-US" dirty="0"/>
               <a:t>单击此处编辑母版文本样式</a:t>
             </a:r>
-            <a:endParaRPr lang="zh-CN" altLang="en-US" dirty="0"/>
           </a:p>
           <a:p>
             <a:pPr lvl="1"/>
@@ -2565,7 +2540,6 @@
               <a:rPr lang="zh-CN" altLang="en-US" dirty="0"/>
               <a:t>第二级</a:t>
             </a:r>
-            <a:endParaRPr lang="zh-CN" altLang="en-US" dirty="0"/>
           </a:p>
           <a:p>
             <a:pPr lvl="2"/>
@@ -2573,7 +2547,6 @@
               <a:rPr lang="zh-CN" altLang="en-US" dirty="0"/>
               <a:t>第三级</a:t>
             </a:r>
-            <a:endParaRPr lang="zh-CN" altLang="en-US" dirty="0"/>
           </a:p>
           <a:p>
             <a:pPr lvl="3"/>
@@ -2581,7 +2554,6 @@
               <a:rPr lang="zh-CN" altLang="en-US" dirty="0"/>
               <a:t>第四级</a:t>
             </a:r>
-            <a:endParaRPr lang="zh-CN" altLang="en-US" dirty="0"/>
           </a:p>
           <a:p>
             <a:pPr lvl="4"/>
@@ -2589,7 +2561,6 @@
               <a:rPr lang="zh-CN" altLang="en-US" dirty="0"/>
               <a:t>第五级</a:t>
             </a:r>
-            <a:endParaRPr lang="zh-CN" altLang="en-US" dirty="0"/>
           </a:p>
         </p:txBody>
       </p:sp>
@@ -2602,7 +2573,7 @@
           <p:nvPr>
             <p:ph type="dt" sz="half" idx="2"/>
             <p:custDataLst>
-              <p:tags r:id="rId14"/>
+              <p:tags r:id="rId16"/>
             </p:custDataLst>
           </p:nvPr>
         </p:nvSpPr>
@@ -2633,6 +2604,7 @@
           <a:p>
             <a:fld id="{760FBDFE-C587-4B4C-A407-44438C67B59E}" type="datetimeFigureOut">
               <a:rPr lang="zh-CN" altLang="en-US" smtClean="0"/>
+              <a:t>2026/8/25</a:t>
             </a:fld>
             <a:endParaRPr lang="zh-CN" altLang="en-US"/>
           </a:p>
@@ -2647,7 +2619,7 @@
           <p:nvPr>
             <p:ph type="ftr" sz="quarter" idx="3"/>
             <p:custDataLst>
-              <p:tags r:id="rId15"/>
+              <p:tags r:id="rId17"/>
             </p:custDataLst>
           </p:nvPr>
         </p:nvSpPr>
@@ -2689,7 +2661,7 @@
           <p:nvPr>
             <p:ph type="sldNum" sz="quarter" idx="4"/>
             <p:custDataLst>
-              <p:tags r:id="rId16"/>
+              <p:tags r:id="rId18"/>
             </p:custDataLst>
           </p:nvPr>
         </p:nvSpPr>
@@ -2720,6 +2692,7 @@
           <a:p>
             <a:fld id="{49AE70B2-8BF9-45C0-BB95-33D1B9D3A854}" type="slidenum">
               <a:rPr lang="zh-CN" altLang="en-US" smtClean="0"/>
+              <a:t>‹#›</a:t>
             </a:fld>
             <a:endParaRPr lang="zh-CN" altLang="en-US" dirty="0"/>
           </a:p>
@@ -2727,7 +2700,7 @@
       </p:sp>
     </p:spTree>
     <p:custDataLst>
-      <p:tags r:id="rId17"/>
+      <p:tags r:id="rId13"/>
     </p:custDataLst>
   </p:cSld>
   <p:clrMap bg1="lt1" tx1="dk1" bg2="lt2" tx2="dk2" accent1="accent1" accent2="accent2" accent3="accent3" accent4="accent4" accent5="accent5" accent6="accent6" hlink="hlink" folHlink="folHlink"/>
@@ -3109,6 +3082,7 @@
           <a:bodyPr wrap="square" rtlCol="0">
             <a:spAutoFit/>
           </a:bodyPr>
+          <a:lstStyle/>
           <a:p>
             <a:r>
               <a:rPr lang="zh-CN" altLang="en-US" sz="3200"/>
@@ -3122,7 +3096,6 @@
               <a:rPr lang="zh-CN" altLang="en-US" sz="3200"/>
               <a:t>教程</a:t>
             </a:r>
-            <a:endParaRPr lang="zh-CN" altLang="en-US" sz="3200"/>
           </a:p>
         </p:txBody>
       </p:sp>
@@ -3146,7 +3119,14 @@
         <p:cNvGrpSpPr/>
         <p:nvPr/>
       </p:nvGrpSpPr>
-      <p:grpSpPr/>
+      <p:grpSpPr>
+        <a:xfrm>
+          <a:off x="0" y="0"/>
+          <a:ext cx="0" cy="0"/>
+          <a:chOff x="0" y="0"/>
+          <a:chExt cx="0" cy="0"/>
+        </a:xfrm>
+      </p:grpSpPr>
       <p:sp>
         <p:nvSpPr>
           <p:cNvPr id="2" name="文本框 1"/>
@@ -3167,6 +3147,7 @@
           <a:bodyPr wrap="square" rtlCol="0">
             <a:spAutoFit/>
           </a:bodyPr>
+          <a:lstStyle/>
           <a:p>
             <a:r>
               <a:rPr lang="en-US" altLang="zh-CN"/>
@@ -3208,17 +3189,12 @@
             </a:r>
             <a:r>
               <a:rPr lang="zh-CN" altLang="en-US"/>
-              <a:t>，</a:t>
-            </a:r>
-            <a:r>
-              <a:rPr lang="zh-CN" altLang="en-US"/>
-              <a:t>再点击生成</a:t>
+              <a:t>，再点击生成</a:t>
             </a:r>
             <a:r>
               <a:rPr lang="en-US" altLang="zh-CN"/>
               <a:t>API</a:t>
             </a:r>
-            <a:endParaRPr lang="en-US" altLang="zh-CN"/>
           </a:p>
           <a:p>
             <a:endParaRPr lang="en-US" altLang="zh-CN"/>
@@ -3244,7 +3220,6 @@
               <a:rPr lang="en-US" altLang="zh-CN"/>
               <a:t>API</a:t>
             </a:r>
-            <a:endParaRPr lang="en-US" altLang="zh-CN"/>
           </a:p>
         </p:txBody>
       </p:sp>
@@ -3257,7 +3232,7 @@
           <p:nvPr/>
         </p:nvPicPr>
         <p:blipFill>
-          <a:blip r:embed="rId1"/>
+          <a:blip r:embed="rId3"/>
           <a:stretch>
             <a:fillRect/>
           </a:stretch>
@@ -3281,7 +3256,7 @@
           <p:nvPr/>
         </p:nvPicPr>
         <p:blipFill>
-          <a:blip r:embed="rId2"/>
+          <a:blip r:embed="rId4"/>
           <a:stretch>
             <a:fillRect/>
           </a:stretch>
@@ -3305,7 +3280,7 @@
           <p:nvPr/>
         </p:nvPicPr>
         <p:blipFill>
-          <a:blip r:embed="rId3"/>
+          <a:blip r:embed="rId5"/>
           <a:stretch>
             <a:fillRect/>
           </a:stretch>
@@ -3356,6 +3331,7 @@
         </p:style>
         <p:txBody>
           <a:bodyPr rtlCol="0" anchor="ctr"/>
+          <a:lstStyle/>
           <a:p>
             <a:pPr algn="ctr"/>
             <a:endParaRPr lang="zh-CN" altLang="en-US"/>
@@ -3398,6 +3374,7 @@
         </p:style>
         <p:txBody>
           <a:bodyPr rtlCol="0" anchor="ctr"/>
+          <a:lstStyle/>
           <a:p>
             <a:pPr algn="ctr"/>
             <a:endParaRPr lang="zh-CN" altLang="en-US"/>
@@ -3440,6 +3417,7 @@
         </p:style>
         <p:txBody>
           <a:bodyPr rtlCol="0" anchor="ctr"/>
+          <a:lstStyle/>
           <a:p>
             <a:pPr algn="ctr"/>
             <a:endParaRPr lang="zh-CN" altLang="en-US"/>
@@ -3466,6 +3444,7 @@
           <a:bodyPr wrap="square" rtlCol="0">
             <a:spAutoFit/>
           </a:bodyPr>
+          <a:lstStyle/>
           <a:p>
             <a:r>
               <a:rPr lang="zh-CN" altLang="en-US" b="1"/>
@@ -3479,13 +3458,12 @@
               <a:rPr lang="zh-CN" altLang="en-US" b="1"/>
               <a:t>教程</a:t>
             </a:r>
-            <a:endParaRPr lang="zh-CN" altLang="en-US" b="1"/>
           </a:p>
         </p:txBody>
       </p:sp>
     </p:spTree>
     <p:custDataLst>
-      <p:tags r:id="rId4"/>
+      <p:tags r:id="rId1"/>
     </p:custDataLst>
   </p:cSld>
   <p:clrMapOvr>
@@ -3503,7 +3481,379 @@
         <p:cNvGrpSpPr/>
         <p:nvPr/>
       </p:nvGrpSpPr>
-      <p:grpSpPr/>
+      <p:grpSpPr>
+        <a:xfrm>
+          <a:off x="0" y="0"/>
+          <a:ext cx="0" cy="0"/>
+          <a:chOff x="0" y="0"/>
+          <a:chExt cx="0" cy="0"/>
+        </a:xfrm>
+      </p:grpSpPr>
+      <p:pic>
+        <p:nvPicPr>
+          <p:cNvPr id="4" name="图片 3"/>
+          <p:cNvPicPr>
+            <a:picLocks noChangeAspect="1"/>
+          </p:cNvPicPr>
+          <p:nvPr/>
+        </p:nvPicPr>
+        <p:blipFill>
+          <a:blip r:embed="rId3"/>
+          <a:stretch>
+            <a:fillRect/>
+          </a:stretch>
+        </p:blipFill>
+        <p:spPr>
+          <a:xfrm>
+            <a:off x="742950" y="922655"/>
+            <a:ext cx="5151755" cy="2255520"/>
+          </a:xfrm>
+          <a:prstGeom prst="rect">
+            <a:avLst/>
+          </a:prstGeom>
+        </p:spPr>
+      </p:pic>
+      <p:sp>
+        <p:nvSpPr>
+          <p:cNvPr id="5" name="文本框 4"/>
+          <p:cNvSpPr txBox="1"/>
+          <p:nvPr/>
+        </p:nvSpPr>
+        <p:spPr>
+          <a:xfrm>
+            <a:off x="483870" y="290830"/>
+            <a:ext cx="4064000" cy="368300"/>
+          </a:xfrm>
+          <a:prstGeom prst="rect">
+            <a:avLst/>
+          </a:prstGeom>
+          <a:noFill/>
+        </p:spPr>
+        <p:txBody>
+          <a:bodyPr wrap="square" rtlCol="0">
+            <a:spAutoFit/>
+          </a:bodyPr>
+          <a:lstStyle/>
+          <a:p>
+            <a:r>
+              <a:rPr lang="zh-CN" altLang="en-US" b="1"/>
+              <a:t>添加自定义提供方</a:t>
+            </a:r>
+            <a:r>
+              <a:rPr lang="en-US" altLang="zh-CN" b="1"/>
+              <a:t>-</a:t>
+            </a:r>
+            <a:r>
+              <a:rPr lang="zh-CN" altLang="en-US" b="1"/>
+              <a:t>使用学校模型</a:t>
+            </a:r>
+          </a:p>
+        </p:txBody>
+      </p:sp>
+      <p:pic>
+        <p:nvPicPr>
+          <p:cNvPr id="6" name="图片 5"/>
+          <p:cNvPicPr>
+            <a:picLocks noChangeAspect="1"/>
+          </p:cNvPicPr>
+          <p:nvPr/>
+        </p:nvPicPr>
+        <p:blipFill>
+          <a:blip r:embed="rId4"/>
+          <a:stretch>
+            <a:fillRect/>
+          </a:stretch>
+        </p:blipFill>
+        <p:spPr>
+          <a:xfrm>
+            <a:off x="6684010" y="387985"/>
+            <a:ext cx="4605655" cy="3893820"/>
+          </a:xfrm>
+          <a:prstGeom prst="rect">
+            <a:avLst/>
+          </a:prstGeom>
+        </p:spPr>
+      </p:pic>
+      <p:sp>
+        <p:nvSpPr>
+          <p:cNvPr id="7" name="文本框 6"/>
+          <p:cNvSpPr txBox="1"/>
+          <p:nvPr/>
+        </p:nvSpPr>
+        <p:spPr>
+          <a:xfrm>
+            <a:off x="380365" y="4087495"/>
+            <a:ext cx="10802620" cy="2584450"/>
+          </a:xfrm>
+          <a:prstGeom prst="rect">
+            <a:avLst/>
+          </a:prstGeom>
+          <a:noFill/>
+        </p:spPr>
+        <p:txBody>
+          <a:bodyPr wrap="square" rtlCol="0">
+            <a:spAutoFit/>
+          </a:bodyPr>
+          <a:lstStyle/>
+          <a:p>
+            <a:r>
+              <a:rPr lang="zh-CN" altLang="en-US"/>
+              <a:t>接口地址：</a:t>
+            </a:r>
+            <a:r>
+              <a:rPr lang="en-US" altLang="zh-CN"/>
+              <a:t>http://10.22.18.12:9901/v1</a:t>
+            </a:r>
+          </a:p>
+          <a:p>
+            <a:r>
+              <a:rPr lang="en-US" altLang="zh-CN"/>
+              <a:t>       </a:t>
+            </a:r>
+          </a:p>
+          <a:p>
+            <a:r>
+              <a:rPr lang="en-US" altLang="zh-CN"/>
+              <a:t> APIKey</a:t>
+            </a:r>
+            <a:r>
+              <a:rPr lang="zh-CN" altLang="en-US"/>
+              <a:t>：学校会统一申请</a:t>
+            </a:r>
+            <a:endParaRPr lang="en-US" altLang="zh-CN"/>
+          </a:p>
+          <a:p>
+            <a:endParaRPr lang="en-US" altLang="zh-CN"/>
+          </a:p>
+          <a:p>
+            <a:r>
+              <a:rPr lang="en-US" altLang="zh-CN"/>
+              <a:t>       Deepseek-v4-flash</a:t>
+            </a:r>
+            <a:r>
+              <a:rPr lang="zh-CN" altLang="en-US"/>
+              <a:t>模型</a:t>
+            </a:r>
+            <a:r>
+              <a:rPr lang="en-US" altLang="zh-CN"/>
+              <a:t>ID：deepseek-v4-flash</a:t>
+            </a:r>
+          </a:p>
+          <a:p>
+            <a:r>
+              <a:rPr lang="en-US" altLang="zh-CN"/>
+              <a:t>       Qwen3.6-35B-A3B</a:t>
+            </a:r>
+            <a:r>
+              <a:rPr lang="zh-CN" altLang="en-US"/>
+              <a:t>模型</a:t>
+            </a:r>
+            <a:r>
+              <a:rPr lang="en-US" altLang="zh-CN"/>
+              <a:t>ID：Qwen3.6-35B-A3B</a:t>
+            </a:r>
+          </a:p>
+          <a:p>
+            <a:r>
+              <a:rPr lang="en-US" altLang="zh-CN"/>
+              <a:t>       Qwen3-VL-8B-Instruct</a:t>
+            </a:r>
+            <a:r>
+              <a:rPr lang="zh-CN" altLang="en-US"/>
+              <a:t>模型</a:t>
+            </a:r>
+            <a:r>
+              <a:rPr lang="en-US" altLang="zh-CN"/>
+              <a:t>ID：Qwen3-VL-8B-Instruct</a:t>
+            </a:r>
+          </a:p>
+          <a:p>
+            <a:r>
+              <a:rPr lang="en-US" altLang="zh-CN"/>
+              <a:t>       Qwen3-Embedding</a:t>
+            </a:r>
+            <a:r>
+              <a:rPr lang="zh-CN" altLang="en-US"/>
+              <a:t>模型</a:t>
+            </a:r>
+            <a:r>
+              <a:rPr lang="en-US" altLang="zh-CN"/>
+              <a:t>ID：Qwen-embedding</a:t>
+            </a:r>
+          </a:p>
+          <a:p>
+            <a:r>
+              <a:rPr lang="en-US" altLang="zh-CN"/>
+              <a:t>       Qwen3-Reranker</a:t>
+            </a:r>
+            <a:r>
+              <a:rPr lang="zh-CN" altLang="en-US"/>
+              <a:t>模型</a:t>
+            </a:r>
+            <a:r>
+              <a:rPr lang="en-US" altLang="zh-CN"/>
+              <a:t>ID：reranker</a:t>
+            </a:r>
+          </a:p>
+        </p:txBody>
+      </p:sp>
+      <p:sp>
+        <p:nvSpPr>
+          <p:cNvPr id="8" name="矩形 7"/>
+          <p:cNvSpPr/>
+          <p:nvPr/>
+        </p:nvSpPr>
+        <p:spPr>
+          <a:xfrm>
+            <a:off x="4107180" y="2823210"/>
+            <a:ext cx="1298575" cy="251460"/>
+          </a:xfrm>
+          <a:prstGeom prst="rect">
+            <a:avLst/>
+          </a:prstGeom>
+          <a:ln w="28575">
+            <a:solidFill>
+              <a:srgbClr val="FF0000"/>
+            </a:solidFill>
+          </a:ln>
+        </p:spPr>
+        <p:style>
+          <a:lnRef idx="3">
+            <a:schemeClr val="accent1"/>
+          </a:lnRef>
+          <a:fillRef idx="0">
+            <a:srgbClr val="FFFFFF"/>
+          </a:fillRef>
+          <a:effectRef idx="0">
+            <a:srgbClr val="FFFFFF"/>
+          </a:effectRef>
+          <a:fontRef idx="minor">
+            <a:schemeClr val="tx1"/>
+          </a:fontRef>
+        </p:style>
+        <p:txBody>
+          <a:bodyPr rtlCol="0" anchor="ctr"/>
+          <a:lstStyle/>
+          <a:p>
+            <a:pPr algn="ctr"/>
+            <a:endParaRPr lang="zh-CN" altLang="en-US"/>
+          </a:p>
+        </p:txBody>
+      </p:sp>
+      <p:sp>
+        <p:nvSpPr>
+          <p:cNvPr id="9" name="矩形 8"/>
+          <p:cNvSpPr/>
+          <p:nvPr/>
+        </p:nvSpPr>
+        <p:spPr>
+          <a:xfrm>
+            <a:off x="7782560" y="1909445"/>
+            <a:ext cx="3400425" cy="364490"/>
+          </a:xfrm>
+          <a:prstGeom prst="rect">
+            <a:avLst/>
+          </a:prstGeom>
+          <a:ln w="28575">
+            <a:solidFill>
+              <a:srgbClr val="FF0000"/>
+            </a:solidFill>
+          </a:ln>
+        </p:spPr>
+        <p:style>
+          <a:lnRef idx="3">
+            <a:schemeClr val="accent1"/>
+          </a:lnRef>
+          <a:fillRef idx="0">
+            <a:srgbClr val="FFFFFF"/>
+          </a:fillRef>
+          <a:effectRef idx="0">
+            <a:srgbClr val="FFFFFF"/>
+          </a:effectRef>
+          <a:fontRef idx="minor">
+            <a:schemeClr val="tx1"/>
+          </a:fontRef>
+        </p:style>
+        <p:txBody>
+          <a:bodyPr rtlCol="0" anchor="ctr"/>
+          <a:lstStyle/>
+          <a:p>
+            <a:pPr algn="ctr"/>
+            <a:endParaRPr lang="zh-CN" altLang="en-US"/>
+          </a:p>
+        </p:txBody>
+      </p:sp>
+      <p:sp>
+        <p:nvSpPr>
+          <p:cNvPr id="10" name="矩形 9"/>
+          <p:cNvSpPr/>
+          <p:nvPr/>
+        </p:nvSpPr>
+        <p:spPr>
+          <a:xfrm>
+            <a:off x="7896225" y="2720340"/>
+            <a:ext cx="3181350" cy="457835"/>
+          </a:xfrm>
+          <a:prstGeom prst="rect">
+            <a:avLst/>
+          </a:prstGeom>
+          <a:ln w="28575">
+            <a:solidFill>
+              <a:srgbClr val="FF0000"/>
+            </a:solidFill>
+          </a:ln>
+        </p:spPr>
+        <p:style>
+          <a:lnRef idx="3">
+            <a:schemeClr val="accent1"/>
+          </a:lnRef>
+          <a:fillRef idx="0">
+            <a:srgbClr val="FFFFFF"/>
+          </a:fillRef>
+          <a:effectRef idx="0">
+            <a:srgbClr val="FFFFFF"/>
+          </a:effectRef>
+          <a:fontRef idx="minor">
+            <a:schemeClr val="tx1"/>
+          </a:fontRef>
+        </p:style>
+        <p:txBody>
+          <a:bodyPr rtlCol="0" anchor="ctr"/>
+          <a:lstStyle/>
+          <a:p>
+            <a:pPr algn="ctr"/>
+            <a:endParaRPr lang="zh-CN" altLang="en-US"/>
+          </a:p>
+        </p:txBody>
+      </p:sp>
+    </p:spTree>
+    <p:custDataLst>
+      <p:tags r:id="rId1"/>
+    </p:custDataLst>
+  </p:cSld>
+  <p:clrMapOvr>
+    <a:masterClrMapping/>
+  </p:clrMapOvr>
+</p:sld>
+</file>
+
+<file path=ppt/slides/slide12.xml><?xml version="1.0" encoding="utf-8"?>
+<p:sld xmlns:a="http://schemas.openxmlformats.org/drawingml/2006/main" xmlns:r="http://schemas.openxmlformats.org/officeDocument/2006/relationships" xmlns:p="http://schemas.openxmlformats.org/presentationml/2006/main">
+  <p:cSld>
+    <p:spTree>
+      <p:nvGrpSpPr>
+        <p:cNvPr id="1" name=""/>
+        <p:cNvGrpSpPr/>
+        <p:nvPr/>
+      </p:nvGrpSpPr>
+      <p:grpSpPr>
+        <a:xfrm>
+          <a:off x="0" y="0"/>
+          <a:ext cx="0" cy="0"/>
+          <a:chOff x="0" y="0"/>
+          <a:chExt cx="0" cy="0"/>
+        </a:xfrm>
+      </p:grpSpPr>
       <p:sp>
         <p:nvSpPr>
           <p:cNvPr id="3" name="内容占位符 2"/>
@@ -3513,13 +3863,14 @@
           <p:nvPr>
             <p:ph idx="1"/>
             <p:custDataLst>
-              <p:tags r:id="rId1"/>
+              <p:tags r:id="rId2"/>
             </p:custDataLst>
           </p:nvPr>
         </p:nvSpPr>
         <p:spPr/>
         <p:txBody>
           <a:bodyPr/>
+          <a:lstStyle/>
           <a:p>
             <a:pPr marL="0" indent="0">
               <a:buNone/>
@@ -3528,7 +3879,6 @@
               <a:rPr lang="zh-CN" altLang="en-US"/>
               <a:t>关闭后启动，打开终端运行</a:t>
             </a:r>
-            <a:endParaRPr lang="zh-CN" altLang="en-US"/>
           </a:p>
           <a:p>
             <a:pPr marL="0" indent="0">
@@ -3538,13 +3888,12 @@
               <a:rPr lang="en-US" altLang="zh-CN"/>
               <a:t>set "DSH_HOME=D:\DeepSeek harness\dsh_data" &amp;&amp; npx -y @deepseek-ai/dsh web</a:t>
             </a:r>
-            <a:endParaRPr lang="en-US" altLang="zh-CN"/>
           </a:p>
         </p:txBody>
       </p:sp>
     </p:spTree>
     <p:custDataLst>
-      <p:tags r:id="rId2"/>
+      <p:tags r:id="rId1"/>
     </p:custDataLst>
   </p:cSld>
   <p:clrMapOvr>
@@ -3589,6 +3938,7 @@
           <a:bodyPr>
             <a:spAutoFit/>
           </a:bodyPr>
+          <a:lstStyle/>
           <a:p>
             <a:pPr marL="0" indent="0" algn="just" defTabSz="266700">
               <a:spcBef>
@@ -3633,10 +3983,6 @@
               </a:rPr>
               <a:t>开放平台</a:t>
             </a:r>
-            <a:endParaRPr lang="zh-CN" altLang="en-US" sz="1600">
-              <a:latin typeface="Calibri" panose="020F0502020204030204"/>
-              <a:ea typeface="宋体" panose="02010600030101010101" pitchFamily="2" charset="-122"/>
-            </a:endParaRPr>
           </a:p>
         </p:txBody>
       </p:sp>
@@ -3649,7 +3995,7 @@
           <p:nvPr/>
         </p:nvPicPr>
         <p:blipFill>
-          <a:blip r:embed="rId1"/>
+          <a:blip r:embed="rId3"/>
           <a:stretch>
             <a:fillRect/>
           </a:stretch>
@@ -3704,6 +4050,7 @@
         </p:style>
         <p:txBody>
           <a:bodyPr rtlCol="0" anchor="ctr"/>
+          <a:lstStyle/>
           <a:p>
             <a:pPr algn="ctr"/>
             <a:endParaRPr lang="zh-CN" altLang="en-US"/>
@@ -3729,6 +4076,7 @@
           <a:bodyPr>
             <a:spAutoFit/>
           </a:bodyPr>
+          <a:lstStyle/>
           <a:p>
             <a:pPr marL="0" indent="0" algn="just" defTabSz="266700">
               <a:spcBef>
@@ -3766,10 +4114,6 @@
               </a:rPr>
               <a:t>KEY</a:t>
             </a:r>
-            <a:endParaRPr lang="en-US" altLang="zh-CN" sz="1600">
-              <a:latin typeface="Calibri" panose="020F0502020204030204"/>
-              <a:ea typeface="Calibri" panose="020F0502020204030204"/>
-            </a:endParaRPr>
           </a:p>
         </p:txBody>
       </p:sp>
@@ -3782,7 +4126,7 @@
           <p:nvPr/>
         </p:nvPicPr>
         <p:blipFill>
-          <a:blip r:embed="rId2"/>
+          <a:blip r:embed="rId4"/>
           <a:stretch>
             <a:fillRect/>
           </a:stretch>
@@ -3837,6 +4181,7 @@
         </p:style>
         <p:txBody>
           <a:bodyPr rtlCol="0" anchor="ctr"/>
+          <a:lstStyle/>
           <a:p>
             <a:pPr algn="ctr"/>
             <a:endParaRPr lang="zh-CN" altLang="en-US"/>
@@ -3879,6 +4224,7 @@
         </p:style>
         <p:txBody>
           <a:bodyPr rtlCol="0" anchor="ctr"/>
+          <a:lstStyle/>
           <a:p>
             <a:pPr algn="ctr"/>
             <a:endParaRPr lang="zh-CN" altLang="en-US"/>
@@ -3894,7 +4240,7 @@
         <p:spPr>
           <a:xfrm>
             <a:off x="401320" y="217170"/>
-            <a:ext cx="4064000" cy="368300"/>
+            <a:ext cx="7387590" cy="368300"/>
           </a:xfrm>
           <a:prstGeom prst="rect">
             <a:avLst/>
@@ -3905,34 +4251,59 @@
           <a:bodyPr wrap="square" rtlCol="0">
             <a:spAutoFit/>
           </a:bodyPr>
-          <a:p>
-            <a:r>
-              <a:rPr lang="en-US" altLang="zh-CN"/>
+          <a:lstStyle/>
+          <a:p>
+            <a:r>
+              <a:rPr lang="en-US" altLang="zh-CN" dirty="0"/>
               <a:t>1.</a:t>
             </a:r>
             <a:r>
-              <a:rPr lang="zh-CN" altLang="en-US"/>
+              <a:rPr lang="zh-CN" altLang="en-US" dirty="0"/>
               <a:t>准备好</a:t>
             </a:r>
             <a:r>
-              <a:rPr lang="en-US" altLang="zh-CN"/>
+              <a:rPr lang="en-US" altLang="zh-CN" dirty="0"/>
               <a:t>DeepSeek</a:t>
             </a:r>
             <a:r>
-              <a:rPr lang="zh-CN" altLang="en-US"/>
+              <a:rPr lang="zh-CN" altLang="en-US" dirty="0"/>
               <a:t>的</a:t>
             </a:r>
             <a:r>
-              <a:rPr lang="en-US" altLang="zh-CN"/>
+              <a:rPr lang="en-US" altLang="zh-CN" dirty="0"/>
               <a:t>API</a:t>
             </a:r>
-            <a:endParaRPr lang="en-US" altLang="zh-CN"/>
+            <a:r>
+              <a:rPr lang="zh-CN" altLang="en-US" dirty="0"/>
+              <a:t>，充值</a:t>
+            </a:r>
+            <a:r>
+              <a:rPr lang="en-US" altLang="zh-CN" dirty="0"/>
+              <a:t>10</a:t>
+            </a:r>
+            <a:r>
+              <a:rPr lang="zh-CN" altLang="en-US" dirty="0"/>
+              <a:t>元可以用很久（</a:t>
+            </a:r>
+            <a:r>
+              <a:rPr lang="zh-CN" altLang="en-US" dirty="0">
+                <a:solidFill>
+                  <a:srgbClr val="C00000"/>
+                </a:solidFill>
+              </a:rPr>
+              <a:t>自由选择</a:t>
+            </a:r>
+            <a:r>
+              <a:rPr lang="en-US" altLang="zh-CN" dirty="0"/>
+              <a:t>)</a:t>
+            </a:r>
+            <a:endParaRPr lang="zh-CN" altLang="en-US" dirty="0"/>
           </a:p>
         </p:txBody>
       </p:sp>
     </p:spTree>
     <p:custDataLst>
-      <p:tags r:id="rId3"/>
+      <p:tags r:id="rId1"/>
     </p:custDataLst>
   </p:cSld>
   <p:clrMapOvr>
@@ -3950,7 +4321,14 @@
         <p:cNvGrpSpPr/>
         <p:nvPr/>
       </p:nvGrpSpPr>
-      <p:grpSpPr/>
+      <p:grpSpPr>
+        <a:xfrm>
+          <a:off x="0" y="0"/>
+          <a:ext cx="0" cy="0"/>
+          <a:chOff x="0" y="0"/>
+          <a:chExt cx="0" cy="0"/>
+        </a:xfrm>
+      </p:grpSpPr>
       <p:pic>
         <p:nvPicPr>
           <p:cNvPr id="6" name="图片 5" descr="屏幕截图 2026-08-23 163340"/>
@@ -3960,7 +4338,7 @@
           <p:nvPr/>
         </p:nvPicPr>
         <p:blipFill>
-          <a:blip r:embed="rId1"/>
+          <a:blip r:embed="rId3"/>
           <a:stretch>
             <a:fillRect/>
           </a:stretch>
@@ -3995,6 +4373,7 @@
           <a:bodyPr wrap="square" rtlCol="0">
             <a:spAutoFit/>
           </a:bodyPr>
+          <a:lstStyle/>
           <a:p>
             <a:r>
               <a:rPr lang="en-US" altLang="zh-CN"/>
@@ -4008,7 +4387,6 @@
               <a:rPr lang="en-US" altLang="zh-CN"/>
               <a:t>node.js</a:t>
             </a:r>
-            <a:endParaRPr lang="en-US" altLang="zh-CN"/>
           </a:p>
         </p:txBody>
       </p:sp>
@@ -4032,6 +4410,7 @@
           <a:bodyPr wrap="square" rtlCol="0">
             <a:spAutoFit/>
           </a:bodyPr>
+          <a:lstStyle/>
           <a:p>
             <a:pPr algn="l">
               <a:buClrTx/>
@@ -4039,23 +4418,26 @@
               <a:buFontTx/>
             </a:pPr>
             <a:r>
-              <a:rPr lang="en-US" altLang="zh-CN" sz="1600">
+              <a:rPr lang="en-US" altLang="zh-CN" sz="1600" dirty="0" err="1">
                 <a:latin typeface="Calibri" panose="020F0502020204030204"/>
                 <a:ea typeface="Calibri" panose="020F0502020204030204"/>
               </a:rPr>
-              <a:t>选择windows or mac</a:t>
-            </a:r>
-            <a:r>
-              <a:rPr lang="zh-CN" altLang="en-US" sz="1600">
+              <a:t>选择windows</a:t>
+            </a:r>
+            <a:r>
+              <a:rPr lang="en-US" altLang="zh-CN" sz="1600" dirty="0">
+                <a:latin typeface="Calibri" panose="020F0502020204030204"/>
+                <a:ea typeface="Calibri" panose="020F0502020204030204"/>
+              </a:rPr>
+              <a:t> or mac</a:t>
+            </a:r>
+            <a:r>
+              <a:rPr lang="zh-CN" altLang="en-US" sz="1600" dirty="0">
                 <a:latin typeface="Calibri" panose="020F0502020204030204"/>
                 <a:ea typeface="Calibri" panose="020F0502020204030204"/>
               </a:rPr>
               <a:t>安装</a:t>
             </a:r>
-            <a:endParaRPr lang="zh-CN" altLang="en-US" sz="1600">
-              <a:latin typeface="Calibri" panose="020F0502020204030204"/>
-              <a:ea typeface="Calibri" panose="020F0502020204030204"/>
-            </a:endParaRPr>
           </a:p>
         </p:txBody>
       </p:sp>
@@ -4095,6 +4477,7 @@
         </p:style>
         <p:txBody>
           <a:bodyPr rtlCol="0" anchor="ctr"/>
+          <a:lstStyle/>
           <a:p>
             <a:pPr algn="ctr"/>
             <a:endParaRPr lang="zh-CN" altLang="en-US"/>
@@ -4137,6 +4520,7 @@
         </p:style>
         <p:txBody>
           <a:bodyPr rtlCol="0" anchor="ctr"/>
+          <a:lstStyle/>
           <a:p>
             <a:pPr algn="ctr"/>
             <a:endParaRPr lang="zh-CN" altLang="en-US"/>
@@ -4145,7 +4529,7 @@
       </p:sp>
     </p:spTree>
     <p:custDataLst>
-      <p:tags r:id="rId2"/>
+      <p:tags r:id="rId1"/>
     </p:custDataLst>
   </p:cSld>
   <p:clrMapOvr>
@@ -4163,7 +4547,14 @@
         <p:cNvGrpSpPr/>
         <p:nvPr/>
       </p:nvGrpSpPr>
-      <p:grpSpPr/>
+      <p:grpSpPr>
+        <a:xfrm>
+          <a:off x="0" y="0"/>
+          <a:ext cx="0" cy="0"/>
+          <a:chOff x="0" y="0"/>
+          <a:chExt cx="0" cy="0"/>
+        </a:xfrm>
+      </p:grpSpPr>
       <p:pic>
         <p:nvPicPr>
           <p:cNvPr id="2" name="图片 1"/>
@@ -4173,7 +4564,7 @@
           <p:nvPr/>
         </p:nvPicPr>
         <p:blipFill>
-          <a:blip r:embed="rId1"/>
+          <a:blip r:embed="rId3"/>
           <a:stretch>
             <a:fillRect/>
           </a:stretch>
@@ -4208,6 +4599,7 @@
           <a:bodyPr wrap="square" rtlCol="0">
             <a:spAutoFit/>
           </a:bodyPr>
+          <a:lstStyle/>
           <a:p>
             <a:r>
               <a:rPr lang="en-US" altLang="zh-CN"/>
@@ -4233,13 +4625,12 @@
               <a:rPr lang="zh-CN" altLang="en-US"/>
               <a:t>运行</a:t>
             </a:r>
-            <a:endParaRPr lang="zh-CN" altLang="en-US"/>
           </a:p>
         </p:txBody>
       </p:sp>
     </p:spTree>
     <p:custDataLst>
-      <p:tags r:id="rId2"/>
+      <p:tags r:id="rId1"/>
     </p:custDataLst>
   </p:cSld>
   <p:clrMapOvr>
@@ -4257,7 +4648,14 @@
         <p:cNvGrpSpPr/>
         <p:nvPr/>
       </p:nvGrpSpPr>
-      <p:grpSpPr/>
+      <p:grpSpPr>
+        <a:xfrm>
+          <a:off x="0" y="0"/>
+          <a:ext cx="0" cy="0"/>
+          <a:chOff x="0" y="0"/>
+          <a:chExt cx="0" cy="0"/>
+        </a:xfrm>
+      </p:grpSpPr>
       <p:sp>
         <p:nvSpPr>
           <p:cNvPr id="4" name="文本框 3"/>
@@ -4278,6 +4676,7 @@
           <a:bodyPr wrap="square" rtlCol="0">
             <a:spAutoFit/>
           </a:bodyPr>
+          <a:lstStyle/>
           <a:p>
             <a:r>
               <a:rPr lang="en-US" altLang="zh-CN"/>
@@ -4287,7 +4686,6 @@
               <a:rPr lang="zh-CN" altLang="en-US"/>
               <a:t>报错</a:t>
             </a:r>
-            <a:endParaRPr lang="zh-CN" altLang="en-US"/>
           </a:p>
         </p:txBody>
       </p:sp>
@@ -4311,6 +4709,7 @@
           <a:bodyPr wrap="square" rtlCol="0">
             <a:spAutoFit/>
           </a:bodyPr>
+          <a:lstStyle/>
           <a:p>
             <a:r>
               <a:rPr lang="zh-CN" altLang="en-US"/>
@@ -4324,7 +4723,6 @@
               <a:rPr lang="zh-CN" altLang="en-US"/>
               <a:t>执行</a:t>
             </a:r>
-            <a:endParaRPr lang="zh-CN" altLang="en-US"/>
           </a:p>
         </p:txBody>
       </p:sp>
@@ -4347,6 +4745,7 @@
           <a:bodyPr wrap="square">
             <a:spAutoFit/>
           </a:bodyPr>
+          <a:lstStyle/>
           <a:p>
             <a:pPr marL="0" indent="0" algn="l"/>
             <a:r>
@@ -4359,13 +4758,6 @@
               </a:rPr>
               <a:t>Set-ExecutionPolicy RemoteSigned -Scope CurrentUser</a:t>
             </a:r>
-            <a:endParaRPr lang="en-US" altLang="zh-CN" sz="1600" b="0" i="0">
-              <a:solidFill>
-                <a:srgbClr val="1F2329"/>
-              </a:solidFill>
-              <a:latin typeface="ui-sans-serif"/>
-              <a:ea typeface="ui-sans-serif"/>
-            </a:endParaRPr>
           </a:p>
         </p:txBody>
       </p:sp>
@@ -4378,7 +4770,7 @@
           <p:nvPr/>
         </p:nvPicPr>
         <p:blipFill>
-          <a:blip r:embed="rId1"/>
+          <a:blip r:embed="rId3"/>
           <a:srcRect l="1012" r="6366" b="32462"/>
           <a:stretch>
             <a:fillRect/>
@@ -4414,6 +4806,7 @@
           <a:bodyPr wrap="square" rtlCol="0">
             <a:spAutoFit/>
           </a:bodyPr>
+          <a:lstStyle/>
           <a:p>
             <a:r>
               <a:rPr lang="zh-CN" altLang="en-US"/>
@@ -4425,19 +4818,14 @@
             </a:r>
             <a:r>
               <a:rPr lang="zh-CN" altLang="en-US"/>
-              <a:t>，</a:t>
-            </a:r>
-            <a:r>
-              <a:rPr lang="zh-CN" altLang="en-US"/>
-              <a:t>回车</a:t>
-            </a:r>
-            <a:endParaRPr lang="zh-CN" altLang="en-US"/>
+              <a:t>，回车</a:t>
+            </a:r>
           </a:p>
         </p:txBody>
       </p:sp>
     </p:spTree>
     <p:custDataLst>
-      <p:tags r:id="rId2"/>
+      <p:tags r:id="rId1"/>
     </p:custDataLst>
   </p:cSld>
   <p:clrMapOvr>
@@ -4455,7 +4843,14 @@
         <p:cNvGrpSpPr/>
         <p:nvPr/>
       </p:nvGrpSpPr>
-      <p:grpSpPr/>
+      <p:grpSpPr>
+        <a:xfrm>
+          <a:off x="0" y="0"/>
+          <a:ext cx="0" cy="0"/>
+          <a:chOff x="0" y="0"/>
+          <a:chExt cx="0" cy="0"/>
+        </a:xfrm>
+      </p:grpSpPr>
       <p:pic>
         <p:nvPicPr>
           <p:cNvPr id="9" name="图片 8"/>
@@ -4465,7 +4860,7 @@
           <p:nvPr/>
         </p:nvPicPr>
         <p:blipFill>
-          <a:blip r:embed="rId1"/>
+          <a:blip r:embed="rId3"/>
           <a:srcRect l="3074" t="3297" b="28768"/>
           <a:stretch>
             <a:fillRect/>
@@ -4501,6 +4896,7 @@
           <a:bodyPr wrap="square" rtlCol="0">
             <a:spAutoFit/>
           </a:bodyPr>
+          <a:lstStyle/>
           <a:p>
             <a:r>
               <a:rPr lang="zh-CN" altLang="en-US"/>
@@ -4510,7 +4906,6 @@
               <a:rPr lang="en-US" altLang="zh-CN"/>
               <a:t>$env:DSH_HOME="D:\DeepSeek harness\dsh_data"; npx -y @deepseek-ai/dsh web</a:t>
             </a:r>
-            <a:endParaRPr lang="en-US" altLang="zh-CN"/>
           </a:p>
         </p:txBody>
       </p:sp>
@@ -4534,26 +4929,18 @@
           <a:bodyPr wrap="square" rtlCol="0">
             <a:spAutoFit/>
           </a:bodyPr>
+          <a:lstStyle/>
           <a:p>
             <a:r>
               <a:rPr lang="zh-CN" altLang="en-US"/>
-              <a:t>光标闪烁，等待</a:t>
-            </a:r>
-            <a:r>
-              <a:rPr lang="zh-CN" altLang="en-US"/>
-              <a:t>安装，时间</a:t>
-            </a:r>
-            <a:r>
-              <a:rPr lang="zh-CN" altLang="en-US"/>
-              <a:t>较长</a:t>
-            </a:r>
-            <a:endParaRPr lang="zh-CN" altLang="en-US"/>
+              <a:t>光标闪烁，等待安装，时间较长</a:t>
+            </a:r>
           </a:p>
         </p:txBody>
       </p:sp>
     </p:spTree>
     <p:custDataLst>
-      <p:tags r:id="rId2"/>
+      <p:tags r:id="rId1"/>
     </p:custDataLst>
   </p:cSld>
   <p:clrMapOvr>
@@ -4571,7 +4958,14 @@
         <p:cNvGrpSpPr/>
         <p:nvPr/>
       </p:nvGrpSpPr>
-      <p:grpSpPr/>
+      <p:grpSpPr>
+        <a:xfrm>
+          <a:off x="0" y="0"/>
+          <a:ext cx="0" cy="0"/>
+          <a:chOff x="0" y="0"/>
+          <a:chExt cx="0" cy="0"/>
+        </a:xfrm>
+      </p:grpSpPr>
       <p:sp>
         <p:nvSpPr>
           <p:cNvPr id="4" name="文本框 3"/>
@@ -4592,6 +4986,7 @@
           <a:bodyPr wrap="square" rtlCol="0">
             <a:spAutoFit/>
           </a:bodyPr>
+          <a:lstStyle/>
           <a:p>
             <a:r>
               <a:rPr lang="en-US" altLang="zh-CN"/>
@@ -4599,13 +4994,8 @@
             </a:r>
             <a:r>
               <a:rPr lang="zh-CN" altLang="en-US"/>
-              <a:t>如果因为权限报错或网不好</a:t>
-            </a:r>
-            <a:r>
-              <a:rPr lang="zh-CN" altLang="en-US"/>
-              <a:t>卡住</a:t>
-            </a:r>
-            <a:endParaRPr lang="zh-CN" altLang="en-US"/>
+              <a:t>如果因为权限报错或网不好卡住</a:t>
+            </a:r>
           </a:p>
         </p:txBody>
       </p:sp>
@@ -4628,6 +5018,7 @@
           <a:bodyPr>
             <a:noAutofit/>
           </a:bodyPr>
+          <a:lstStyle/>
           <a:p>
             <a:pPr marL="0" indent="0" algn="l">
               <a:lnSpc>
@@ -4649,11 +5040,6 @@
               </a:rPr>
               <a:t>先换国内镜像源（避免网络慢卡住）</a:t>
             </a:r>
-            <a:endParaRPr lang="zh-CN" altLang="en-US" sz="1600" b="0">
-              <a:solidFill>
-                <a:srgbClr val="1F2329"/>
-              </a:solidFill>
-            </a:endParaRPr>
           </a:p>
           <a:p>
             <a:pPr marL="0" indent="0" algn="l">
@@ -4675,11 +5061,6 @@
               </a:rPr>
               <a:t>npm config set registry https://registry.npmmirror.com</a:t>
             </a:r>
-            <a:endParaRPr lang="en-US" altLang="zh-CN" sz="1600" b="0">
-              <a:solidFill>
-                <a:srgbClr val="1F2329"/>
-              </a:solidFill>
-            </a:endParaRPr>
           </a:p>
           <a:p>
             <a:pPr marL="0" indent="0" algn="l">
@@ -4701,11 +5082,6 @@
               </a:rPr>
               <a:t>这一步不是必须的，但能大大提速</a:t>
             </a:r>
-            <a:endParaRPr lang="zh-CN" altLang="en-US" sz="1600" b="0">
-              <a:solidFill>
-                <a:srgbClr val="1F2329"/>
-              </a:solidFill>
-            </a:endParaRPr>
           </a:p>
           <a:p>
             <a:pPr marL="0" indent="0" algn="l">
@@ -4736,11 +5112,6 @@
               </a:rPr>
               <a:t>用管理员权限安装</a:t>
             </a:r>
-            <a:endParaRPr lang="zh-CN" altLang="en-US" sz="1600" b="0">
-              <a:solidFill>
-                <a:srgbClr val="1F2329"/>
-              </a:solidFill>
-            </a:endParaRPr>
           </a:p>
           <a:p>
             <a:pPr marL="0" indent="0" algn="l">
@@ -4762,11 +5133,6 @@
               </a:rPr>
               <a:t>sudo npm install -g @deepseek-ai/dsh</a:t>
             </a:r>
-            <a:endParaRPr lang="en-US" altLang="zh-CN" sz="1600" b="0">
-              <a:solidFill>
-                <a:srgbClr val="1F2329"/>
-              </a:solidFill>
-            </a:endParaRPr>
           </a:p>
           <a:p>
             <a:pPr marL="0" indent="0" algn="l">
@@ -4804,11 +5170,6 @@
               </a:rPr>
               <a:t>的密码）</a:t>
             </a:r>
-            <a:endParaRPr lang="zh-CN" altLang="en-US" sz="1600" b="0">
-              <a:solidFill>
-                <a:srgbClr val="1F2329"/>
-              </a:solidFill>
-            </a:endParaRPr>
           </a:p>
           <a:p>
             <a:pPr marL="0" indent="0" algn="l">
@@ -4864,11 +5225,6 @@
               </a:rPr>
               <a:t>，这是正常的，输完按回车就行</a:t>
             </a:r>
-            <a:endParaRPr lang="zh-CN" altLang="en-US" sz="1600" b="0">
-              <a:solidFill>
-                <a:srgbClr val="1F2329"/>
-              </a:solidFill>
-            </a:endParaRPr>
           </a:p>
           <a:p>
             <a:pPr marL="0" indent="0" algn="l">
@@ -4892,11 +5248,6 @@
               </a:rPr>
               <a:t>然后你会看到进度条和安装过程，等待完成即可</a:t>
             </a:r>
-            <a:endParaRPr lang="zh-CN" altLang="en-US" sz="1600" b="0">
-              <a:solidFill>
-                <a:srgbClr val="1F2329"/>
-              </a:solidFill>
-            </a:endParaRPr>
           </a:p>
         </p:txBody>
       </p:sp>
@@ -4920,7 +5271,14 @@
         <p:cNvGrpSpPr/>
         <p:nvPr/>
       </p:nvGrpSpPr>
-      <p:grpSpPr/>
+      <p:grpSpPr>
+        <a:xfrm>
+          <a:off x="0" y="0"/>
+          <a:ext cx="0" cy="0"/>
+          <a:chOff x="0" y="0"/>
+          <a:chExt cx="0" cy="0"/>
+        </a:xfrm>
+      </p:grpSpPr>
       <p:pic>
         <p:nvPicPr>
           <p:cNvPr id="2" name="图片 1"/>
@@ -4930,7 +5288,7 @@
           <p:nvPr/>
         </p:nvPicPr>
         <p:blipFill>
-          <a:blip r:embed="rId1"/>
+          <a:blip r:embed="rId3"/>
           <a:stretch>
             <a:fillRect/>
           </a:stretch>
@@ -4965,6 +5323,7 @@
           <a:bodyPr wrap="square" rtlCol="0">
             <a:spAutoFit/>
           </a:bodyPr>
+          <a:lstStyle/>
           <a:p>
             <a:r>
               <a:rPr lang="en-US" altLang="zh-CN"/>
@@ -4980,19 +5339,14 @@
             </a:r>
             <a:r>
               <a:rPr lang="zh-CN" altLang="en-US"/>
-              <a:t>的</a:t>
-            </a:r>
-            <a:r>
-              <a:rPr lang="zh-CN" altLang="en-US"/>
-              <a:t>窗口</a:t>
-            </a:r>
-            <a:endParaRPr lang="zh-CN" altLang="en-US"/>
+              <a:t>的窗口</a:t>
+            </a:r>
           </a:p>
         </p:txBody>
       </p:sp>
     </p:spTree>
     <p:custDataLst>
-      <p:tags r:id="rId2"/>
+      <p:tags r:id="rId1"/>
     </p:custDataLst>
   </p:cSld>
   <p:clrMapOvr>
@@ -5010,7 +5364,14 @@
         <p:cNvGrpSpPr/>
         <p:nvPr/>
       </p:nvGrpSpPr>
-      <p:grpSpPr/>
+      <p:grpSpPr>
+        <a:xfrm>
+          <a:off x="0" y="0"/>
+          <a:ext cx="0" cy="0"/>
+          <a:chOff x="0" y="0"/>
+          <a:chExt cx="0" cy="0"/>
+        </a:xfrm>
+      </p:grpSpPr>
       <p:pic>
         <p:nvPicPr>
           <p:cNvPr id="3" name="图片 2" descr="屏幕截图 2026-08-23 214758"/>
@@ -5020,7 +5381,7 @@
           <p:nvPr/>
         </p:nvPicPr>
         <p:blipFill>
-          <a:blip r:embed="rId1"/>
+          <a:blip r:embed="rId3"/>
           <a:stretch>
             <a:fillRect/>
           </a:stretch>
@@ -5044,7 +5405,7 @@
         <p:spPr>
           <a:xfrm>
             <a:off x="401955" y="271780"/>
-            <a:ext cx="4064000" cy="368300"/>
+            <a:ext cx="6583680" cy="368300"/>
           </a:xfrm>
           <a:prstGeom prst="rect">
             <a:avLst/>
@@ -5055,6 +5416,7 @@
           <a:bodyPr wrap="square" rtlCol="0">
             <a:spAutoFit/>
           </a:bodyPr>
+          <a:lstStyle/>
           <a:p>
             <a:r>
               <a:rPr lang="en-US" altLang="zh-CN"/>
@@ -5070,13 +5432,8 @@
             </a:r>
             <a:r>
               <a:rPr lang="zh-CN" altLang="en-US"/>
-              <a:t>模型，可切换英伟达的</a:t>
-            </a:r>
-            <a:r>
-              <a:rPr lang="zh-CN" altLang="en-US"/>
-              <a:t>模型</a:t>
-            </a:r>
-            <a:endParaRPr lang="zh-CN" altLang="en-US"/>
+              <a:t>模型，添加提供方，可切换英伟达的模型</a:t>
+            </a:r>
           </a:p>
         </p:txBody>
       </p:sp>
@@ -5088,8 +5445,8 @@
         </p:nvSpPr>
         <p:spPr>
           <a:xfrm>
-            <a:off x="9044940" y="1922780"/>
-            <a:ext cx="4064000" cy="1198880"/>
+            <a:off x="8880475" y="1922780"/>
+            <a:ext cx="4064000" cy="1476375"/>
           </a:xfrm>
           <a:prstGeom prst="rect">
             <a:avLst/>
@@ -5100,39 +5457,42 @@
           <a:bodyPr wrap="square" rtlCol="0">
             <a:spAutoFit/>
           </a:bodyPr>
+          <a:lstStyle/>
           <a:p>
             <a:r>
               <a:rPr lang="zh-CN" altLang="en-US"/>
               <a:t>推荐模型：</a:t>
             </a:r>
-            <a:endParaRPr lang="zh-CN" altLang="en-US"/>
+          </a:p>
+          <a:p>
+            <a:r>
+              <a:rPr lang="en-US" altLang="zh-CN">
+                <a:sym typeface="+mn-ea"/>
+              </a:rPr>
+              <a:t>nemotron-3-ultra-550b-a55b</a:t>
+            </a:r>
+            <a:endParaRPr lang="en-US" altLang="zh-CN"/>
           </a:p>
           <a:p>
             <a:r>
               <a:rPr lang="en-US" altLang="zh-CN"/>
               <a:t>nemotron-3-nano-30b-a3b</a:t>
             </a:r>
-            <a:endParaRPr lang="en-US" altLang="zh-CN"/>
           </a:p>
           <a:p>
             <a:r>
               <a:rPr lang="en-US" altLang="zh-CN"/>
               <a:t>minimax-m3</a:t>
             </a:r>
-            <a:endParaRPr lang="en-US" altLang="zh-CN"/>
-          </a:p>
-          <a:p>
-            <a:r>
-              <a:rPr lang="en-US" altLang="zh-CN"/>
-              <a:t>nemotron-3-ultra-550b-a55b</a:t>
-            </a:r>
+          </a:p>
+          <a:p>
             <a:endParaRPr lang="en-US" altLang="zh-CN"/>
           </a:p>
         </p:txBody>
       </p:sp>
     </p:spTree>
     <p:custDataLst>
-      <p:tags r:id="rId2"/>
+      <p:tags r:id="rId1"/>
     </p:custDataLst>
   </p:cSld>
   <p:clrMapOvr>
@@ -5142,7 +5502,21 @@
 </file>
 
 <file path=ppt/tags/tag1.xml><?xml version="1.0" encoding="utf-8"?>
-<p:tagLst xmlns:p="http://schemas.openxmlformats.org/presentationml/2006/main">
+<p:tagLst xmlns:a="http://schemas.openxmlformats.org/drawingml/2006/main" xmlns:r="http://schemas.openxmlformats.org/officeDocument/2006/relationships" xmlns:p="http://schemas.openxmlformats.org/presentationml/2006/main">
+  <p:tag name="KSO_WM_TEMPLATE_THUMBS_INDEX" val="1、4、7、12、13、14、15、16、17、18、20、24、25、28、33、36、40、43、44"/>
+  <p:tag name="KSO_WM_TEMPLATE_SUBCATEGORY" val="19"/>
+  <p:tag name="KSO_WM_TAG_VERSION" val="1.0"/>
+  <p:tag name="KSO_WM_BEAUTIFY_FLAG" val="#wm#"/>
+  <p:tag name="KSO_WM_TEMPLATE_CATEGORY" val="custom"/>
+  <p:tag name="KSO_WM_TEMPLATE_INDEX" val="20205081"/>
+  <p:tag name="KSO_WM_TEMPLATE_MASTER_TYPE" val="0"/>
+  <p:tag name="KSO_WM_TEMPLATE_COLOR_TYPE" val="1"/>
+  <p:tag name="KSO_WM_UNIT_SHOW_EDIT_AREA_INDICATION" val="1"/>
+</p:tagLst>
+</file>
+
+<file path=ppt/tags/tag10.xml><?xml version="1.0" encoding="utf-8"?>
+<p:tagLst xmlns:a="http://schemas.openxmlformats.org/drawingml/2006/main" xmlns:r="http://schemas.openxmlformats.org/officeDocument/2006/relationships" xmlns:p="http://schemas.openxmlformats.org/presentationml/2006/main">
   <p:tag name="KSO_WM_UNIT_HIGHLIGHT" val="0"/>
   <p:tag name="KSO_WM_UNIT_COMPATIBLE" val="0"/>
   <p:tag name="KSO_WM_UNIT_DIAGRAM_ISNUMVISUAL" val="0"/>
@@ -5154,8 +5528,21 @@
 </p:tagLst>
 </file>
 
-<file path=ppt/tags/tag10.xml><?xml version="1.0" encoding="utf-8"?>
-<p:tagLst xmlns:p="http://schemas.openxmlformats.org/presentationml/2006/main">
+<file path=ppt/tags/tag11.xml><?xml version="1.0" encoding="utf-8"?>
+<p:tagLst xmlns:a="http://schemas.openxmlformats.org/drawingml/2006/main" xmlns:r="http://schemas.openxmlformats.org/officeDocument/2006/relationships" xmlns:p="http://schemas.openxmlformats.org/presentationml/2006/main">
+  <p:tag name="KSO_WM_UNIT_HIGHLIGHT" val="0"/>
+  <p:tag name="KSO_WM_UNIT_COMPATIBLE" val="0"/>
+  <p:tag name="KSO_WM_UNIT_DIAGRAM_ISNUMVISUAL" val="0"/>
+  <p:tag name="KSO_WM_UNIT_DIAGRAM_ISREFERUNIT" val="0"/>
+  <p:tag name="KSO_WM_UNIT_ID" val="_1**"/>
+  <p:tag name="KSO_WM_UNIT_LAYERLEVEL" val="1"/>
+  <p:tag name="KSO_WM_TAG_VERSION" val="1.0"/>
+  <p:tag name="KSO_WM_BEAUTIFY_FLAG" val="#wm#"/>
+</p:tagLst>
+</file>
+
+<file path=ppt/tags/tag12.xml><?xml version="1.0" encoding="utf-8"?>
+<p:tagLst xmlns:a="http://schemas.openxmlformats.org/drawingml/2006/main" xmlns:r="http://schemas.openxmlformats.org/officeDocument/2006/relationships" xmlns:p="http://schemas.openxmlformats.org/presentationml/2006/main">
   <p:tag name="KSO_WM_UNIT_HIGHLIGHT" val="0"/>
   <p:tag name="KSO_WM_UNIT_COMPATIBLE" val="0"/>
   <p:tag name="KSO_WM_UNIT_DIAGRAM_ISNUMVISUAL" val="0"/>
@@ -5167,8 +5554,60 @@
 </p:tagLst>
 </file>
 
-<file path=ppt/tags/tag11.xml><?xml version="1.0" encoding="utf-8"?>
-<p:tagLst xmlns:p="http://schemas.openxmlformats.org/presentationml/2006/main">
+<file path=ppt/tags/tag13.xml><?xml version="1.0" encoding="utf-8"?>
+<p:tagLst xmlns:a="http://schemas.openxmlformats.org/drawingml/2006/main" xmlns:r="http://schemas.openxmlformats.org/officeDocument/2006/relationships" xmlns:p="http://schemas.openxmlformats.org/presentationml/2006/main">
+  <p:tag name="KSO_WM_UNIT_HIGHLIGHT" val="0"/>
+  <p:tag name="KSO_WM_UNIT_COMPATIBLE" val="0"/>
+  <p:tag name="KSO_WM_UNIT_DIAGRAM_ISNUMVISUAL" val="0"/>
+  <p:tag name="KSO_WM_UNIT_DIAGRAM_ISREFERUNIT" val="0"/>
+  <p:tag name="KSO_WM_UNIT_ID" val="_2**"/>
+  <p:tag name="KSO_WM_UNIT_LAYERLEVEL" val="1"/>
+  <p:tag name="KSO_WM_TAG_VERSION" val="1.0"/>
+  <p:tag name="KSO_WM_BEAUTIFY_FLAG" val="#wm#"/>
+</p:tagLst>
+</file>
+
+<file path=ppt/tags/tag14.xml><?xml version="1.0" encoding="utf-8"?>
+<p:tagLst xmlns:a="http://schemas.openxmlformats.org/drawingml/2006/main" xmlns:r="http://schemas.openxmlformats.org/officeDocument/2006/relationships" xmlns:p="http://schemas.openxmlformats.org/presentationml/2006/main">
+  <p:tag name="KSO_WM_UNIT_HIGHLIGHT" val="0"/>
+  <p:tag name="KSO_WM_UNIT_COMPATIBLE" val="0"/>
+  <p:tag name="KSO_WM_UNIT_DIAGRAM_ISNUMVISUAL" val="0"/>
+  <p:tag name="KSO_WM_UNIT_DIAGRAM_ISREFERUNIT" val="0"/>
+  <p:tag name="KSO_WM_UNIT_ID" val="_2**"/>
+  <p:tag name="KSO_WM_UNIT_LAYERLEVEL" val="1"/>
+  <p:tag name="KSO_WM_TAG_VERSION" val="1.0"/>
+  <p:tag name="KSO_WM_BEAUTIFY_FLAG" val="#wm#"/>
+</p:tagLst>
+</file>
+
+<file path=ppt/tags/tag15.xml><?xml version="1.0" encoding="utf-8"?>
+<p:tagLst xmlns:a="http://schemas.openxmlformats.org/drawingml/2006/main" xmlns:r="http://schemas.openxmlformats.org/officeDocument/2006/relationships" xmlns:p="http://schemas.openxmlformats.org/presentationml/2006/main">
+  <p:tag name="KSO_WM_UNIT_HIGHLIGHT" val="0"/>
+  <p:tag name="KSO_WM_UNIT_COMPATIBLE" val="0"/>
+  <p:tag name="KSO_WM_UNIT_DIAGRAM_ISNUMVISUAL" val="0"/>
+  <p:tag name="KSO_WM_UNIT_DIAGRAM_ISREFERUNIT" val="0"/>
+  <p:tag name="KSO_WM_UNIT_ID" val="_2**"/>
+  <p:tag name="KSO_WM_UNIT_LAYERLEVEL" val="1"/>
+  <p:tag name="KSO_WM_TAG_VERSION" val="1.0"/>
+  <p:tag name="KSO_WM_BEAUTIFY_FLAG" val="#wm#"/>
+</p:tagLst>
+</file>
+
+<file path=ppt/tags/tag16.xml><?xml version="1.0" encoding="utf-8"?>
+<p:tagLst xmlns:a="http://schemas.openxmlformats.org/drawingml/2006/main" xmlns:r="http://schemas.openxmlformats.org/officeDocument/2006/relationships" xmlns:p="http://schemas.openxmlformats.org/presentationml/2006/main">
+  <p:tag name="KSO_WM_UNIT_HIGHLIGHT" val="0"/>
+  <p:tag name="KSO_WM_UNIT_COMPATIBLE" val="0"/>
+  <p:tag name="KSO_WM_UNIT_DIAGRAM_ISNUMVISUAL" val="0"/>
+  <p:tag name="KSO_WM_UNIT_DIAGRAM_ISREFERUNIT" val="0"/>
+  <p:tag name="KSO_WM_UNIT_ID" val="_2**"/>
+  <p:tag name="KSO_WM_UNIT_LAYERLEVEL" val="1"/>
+  <p:tag name="KSO_WM_TAG_VERSION" val="1.0"/>
+  <p:tag name="KSO_WM_BEAUTIFY_FLAG" val="#wm#"/>
+</p:tagLst>
+</file>
+
+<file path=ppt/tags/tag17.xml><?xml version="1.0" encoding="utf-8"?>
+<p:tagLst xmlns:a="http://schemas.openxmlformats.org/drawingml/2006/main" xmlns:r="http://schemas.openxmlformats.org/officeDocument/2006/relationships" xmlns:p="http://schemas.openxmlformats.org/presentationml/2006/main">
   <p:tag name="KSO_WM_UNIT_HIGHLIGHT" val="0"/>
   <p:tag name="KSO_WM_UNIT_COMPATIBLE" val="0"/>
   <p:tag name="KSO_WM_UNIT_DIAGRAM_ISNUMVISUAL" val="0"/>
@@ -5180,8 +5619,8 @@
 </p:tagLst>
 </file>
 
-<file path=ppt/tags/tag12.xml><?xml version="1.0" encoding="utf-8"?>
-<p:tagLst xmlns:p="http://schemas.openxmlformats.org/presentationml/2006/main">
+<file path=ppt/tags/tag18.xml><?xml version="1.0" encoding="utf-8"?>
+<p:tagLst xmlns:a="http://schemas.openxmlformats.org/drawingml/2006/main" xmlns:r="http://schemas.openxmlformats.org/officeDocument/2006/relationships" xmlns:p="http://schemas.openxmlformats.org/presentationml/2006/main">
   <p:tag name="KSO_WM_UNIT_HIGHLIGHT" val="0"/>
   <p:tag name="KSO_WM_UNIT_COMPATIBLE" val="0"/>
   <p:tag name="KSO_WM_UNIT_DIAGRAM_ISNUMVISUAL" val="0"/>
@@ -5193,8 +5632,8 @@
 </p:tagLst>
 </file>
 
-<file path=ppt/tags/tag13.xml><?xml version="1.0" encoding="utf-8"?>
-<p:tagLst xmlns:p="http://schemas.openxmlformats.org/presentationml/2006/main">
+<file path=ppt/tags/tag19.xml><?xml version="1.0" encoding="utf-8"?>
+<p:tagLst xmlns:a="http://schemas.openxmlformats.org/drawingml/2006/main" xmlns:r="http://schemas.openxmlformats.org/officeDocument/2006/relationships" xmlns:p="http://schemas.openxmlformats.org/presentationml/2006/main">
   <p:tag name="KSO_WM_UNIT_HIGHLIGHT" val="0"/>
   <p:tag name="KSO_WM_UNIT_COMPATIBLE" val="0"/>
   <p:tag name="KSO_WM_UNIT_DIAGRAM_ISNUMVISUAL" val="0"/>
@@ -5206,8 +5645,23 @@
 </p:tagLst>
 </file>
 
-<file path=ppt/tags/tag14.xml><?xml version="1.0" encoding="utf-8"?>
-<p:tagLst xmlns:p="http://schemas.openxmlformats.org/presentationml/2006/main">
+<file path=ppt/tags/tag2.xml><?xml version="1.0" encoding="utf-8"?>
+<p:tagLst xmlns:a="http://schemas.openxmlformats.org/drawingml/2006/main" xmlns:r="http://schemas.openxmlformats.org/officeDocument/2006/relationships" xmlns:p="http://schemas.openxmlformats.org/presentationml/2006/main">
+  <p:tag name="KSO_WM_UNIT_HIGHLIGHT" val="0"/>
+  <p:tag name="KSO_WM_UNIT_COMPATIBLE" val="0"/>
+  <p:tag name="KSO_WM_UNIT_DIAGRAM_ISNUMVISUAL" val="0"/>
+  <p:tag name="KSO_WM_UNIT_DIAGRAM_ISREFERUNIT" val="0"/>
+  <p:tag name="KSO_WM_UNIT_ID" val="_0**"/>
+  <p:tag name="KSO_WM_UNIT_LAYERLEVEL" val="1"/>
+  <p:tag name="KSO_WM_TAG_VERSION" val="1.0"/>
+  <p:tag name="KSO_WM_BEAUTIFY_FLAG" val="#wm#"/>
+  <p:tag name="KSO_WM_TEMPLATE_CATEGORY" val="custom"/>
+  <p:tag name="KSO_WM_TEMPLATE_INDEX" val="20205081"/>
+</p:tagLst>
+</file>
+
+<file path=ppt/tags/tag20.xml><?xml version="1.0" encoding="utf-8"?>
+<p:tagLst xmlns:a="http://schemas.openxmlformats.org/drawingml/2006/main" xmlns:r="http://schemas.openxmlformats.org/officeDocument/2006/relationships" xmlns:p="http://schemas.openxmlformats.org/presentationml/2006/main">
   <p:tag name="KSO_WM_UNIT_HIGHLIGHT" val="0"/>
   <p:tag name="KSO_WM_UNIT_COMPATIBLE" val="0"/>
   <p:tag name="KSO_WM_UNIT_DIAGRAM_ISNUMVISUAL" val="0"/>
@@ -5219,8 +5673,8 @@
 </p:tagLst>
 </file>
 
-<file path=ppt/tags/tag15.xml><?xml version="1.0" encoding="utf-8"?>
-<p:tagLst xmlns:p="http://schemas.openxmlformats.org/presentationml/2006/main">
+<file path=ppt/tags/tag21.xml><?xml version="1.0" encoding="utf-8"?>
+<p:tagLst xmlns:a="http://schemas.openxmlformats.org/drawingml/2006/main" xmlns:r="http://schemas.openxmlformats.org/officeDocument/2006/relationships" xmlns:p="http://schemas.openxmlformats.org/presentationml/2006/main">
   <p:tag name="KSO_WM_UNIT_HIGHLIGHT" val="0"/>
   <p:tag name="KSO_WM_UNIT_COMPATIBLE" val="0"/>
   <p:tag name="KSO_WM_UNIT_DIAGRAM_ISNUMVISUAL" val="0"/>
@@ -5232,8 +5686,8 @@
 </p:tagLst>
 </file>
 
-<file path=ppt/tags/tag16.xml><?xml version="1.0" encoding="utf-8"?>
-<p:tagLst xmlns:p="http://schemas.openxmlformats.org/presentationml/2006/main">
+<file path=ppt/tags/tag22.xml><?xml version="1.0" encoding="utf-8"?>
+<p:tagLst xmlns:a="http://schemas.openxmlformats.org/drawingml/2006/main" xmlns:r="http://schemas.openxmlformats.org/officeDocument/2006/relationships" xmlns:p="http://schemas.openxmlformats.org/presentationml/2006/main">
   <p:tag name="KSO_WM_UNIT_HIGHLIGHT" val="0"/>
   <p:tag name="KSO_WM_UNIT_COMPATIBLE" val="0"/>
   <p:tag name="KSO_WM_UNIT_DIAGRAM_ISNUMVISUAL" val="0"/>
@@ -5245,8 +5699,8 @@
 </p:tagLst>
 </file>
 
-<file path=ppt/tags/tag17.xml><?xml version="1.0" encoding="utf-8"?>
-<p:tagLst xmlns:p="http://schemas.openxmlformats.org/presentationml/2006/main">
+<file path=ppt/tags/tag23.xml><?xml version="1.0" encoding="utf-8"?>
+<p:tagLst xmlns:a="http://schemas.openxmlformats.org/drawingml/2006/main" xmlns:r="http://schemas.openxmlformats.org/officeDocument/2006/relationships" xmlns:p="http://schemas.openxmlformats.org/presentationml/2006/main">
   <p:tag name="KSO_WM_UNIT_HIGHLIGHT" val="0"/>
   <p:tag name="KSO_WM_UNIT_COMPATIBLE" val="0"/>
   <p:tag name="KSO_WM_UNIT_DIAGRAM_ISNUMVISUAL" val="0"/>
@@ -5258,8 +5712,8 @@
 </p:tagLst>
 </file>
 
-<file path=ppt/tags/tag18.xml><?xml version="1.0" encoding="utf-8"?>
-<p:tagLst xmlns:p="http://schemas.openxmlformats.org/presentationml/2006/main">
+<file path=ppt/tags/tag24.xml><?xml version="1.0" encoding="utf-8"?>
+<p:tagLst xmlns:a="http://schemas.openxmlformats.org/drawingml/2006/main" xmlns:r="http://schemas.openxmlformats.org/officeDocument/2006/relationships" xmlns:p="http://schemas.openxmlformats.org/presentationml/2006/main">
   <p:tag name="KSO_WM_UNIT_HIGHLIGHT" val="0"/>
   <p:tag name="KSO_WM_UNIT_COMPATIBLE" val="0"/>
   <p:tag name="KSO_WM_UNIT_DIAGRAM_ISNUMVISUAL" val="0"/>
@@ -5271,8 +5725,8 @@
 </p:tagLst>
 </file>
 
-<file path=ppt/tags/tag19.xml><?xml version="1.0" encoding="utf-8"?>
-<p:tagLst xmlns:p="http://schemas.openxmlformats.org/presentationml/2006/main">
+<file path=ppt/tags/tag25.xml><?xml version="1.0" encoding="utf-8"?>
+<p:tagLst xmlns:a="http://schemas.openxmlformats.org/drawingml/2006/main" xmlns:r="http://schemas.openxmlformats.org/officeDocument/2006/relationships" xmlns:p="http://schemas.openxmlformats.org/presentationml/2006/main">
   <p:tag name="KSO_WM_UNIT_HIGHLIGHT" val="0"/>
   <p:tag name="KSO_WM_UNIT_COMPATIBLE" val="0"/>
   <p:tag name="KSO_WM_UNIT_DIAGRAM_ISNUMVISUAL" val="0"/>
@@ -5284,21 +5738,8 @@
 </p:tagLst>
 </file>
 
-<file path=ppt/tags/tag2.xml><?xml version="1.0" encoding="utf-8"?>
-<p:tagLst xmlns:p="http://schemas.openxmlformats.org/presentationml/2006/main">
-  <p:tag name="KSO_WM_UNIT_HIGHLIGHT" val="0"/>
-  <p:tag name="KSO_WM_UNIT_COMPATIBLE" val="0"/>
-  <p:tag name="KSO_WM_UNIT_DIAGRAM_ISNUMVISUAL" val="0"/>
-  <p:tag name="KSO_WM_UNIT_DIAGRAM_ISREFERUNIT" val="0"/>
-  <p:tag name="KSO_WM_UNIT_ID" val="_1**"/>
-  <p:tag name="KSO_WM_UNIT_LAYERLEVEL" val="1"/>
-  <p:tag name="KSO_WM_TAG_VERSION" val="1.0"/>
-  <p:tag name="KSO_WM_BEAUTIFY_FLAG" val="#wm#"/>
-</p:tagLst>
-</file>
-
-<file path=ppt/tags/tag20.xml><?xml version="1.0" encoding="utf-8"?>
-<p:tagLst xmlns:p="http://schemas.openxmlformats.org/presentationml/2006/main">
+<file path=ppt/tags/tag26.xml><?xml version="1.0" encoding="utf-8"?>
+<p:tagLst xmlns:a="http://schemas.openxmlformats.org/drawingml/2006/main" xmlns:r="http://schemas.openxmlformats.org/officeDocument/2006/relationships" xmlns:p="http://schemas.openxmlformats.org/presentationml/2006/main">
   <p:tag name="KSO_WM_UNIT_HIGHLIGHT" val="0"/>
   <p:tag name="KSO_WM_UNIT_COMPATIBLE" val="0"/>
   <p:tag name="KSO_WM_UNIT_DIAGRAM_ISNUMVISUAL" val="0"/>
@@ -5310,8 +5751,8 @@
 </p:tagLst>
 </file>
 
-<file path=ppt/tags/tag21.xml><?xml version="1.0" encoding="utf-8"?>
-<p:tagLst xmlns:p="http://schemas.openxmlformats.org/presentationml/2006/main">
+<file path=ppt/tags/tag27.xml><?xml version="1.0" encoding="utf-8"?>
+<p:tagLst xmlns:a="http://schemas.openxmlformats.org/drawingml/2006/main" xmlns:r="http://schemas.openxmlformats.org/officeDocument/2006/relationships" xmlns:p="http://schemas.openxmlformats.org/presentationml/2006/main">
   <p:tag name="KSO_WM_UNIT_HIGHLIGHT" val="0"/>
   <p:tag name="KSO_WM_UNIT_COMPATIBLE" val="0"/>
   <p:tag name="KSO_WM_UNIT_DIAGRAM_ISNUMVISUAL" val="0"/>
@@ -5323,8 +5764,8 @@
 </p:tagLst>
 </file>
 
-<file path=ppt/tags/tag22.xml><?xml version="1.0" encoding="utf-8"?>
-<p:tagLst xmlns:p="http://schemas.openxmlformats.org/presentationml/2006/main">
+<file path=ppt/tags/tag28.xml><?xml version="1.0" encoding="utf-8"?>
+<p:tagLst xmlns:a="http://schemas.openxmlformats.org/drawingml/2006/main" xmlns:r="http://schemas.openxmlformats.org/officeDocument/2006/relationships" xmlns:p="http://schemas.openxmlformats.org/presentationml/2006/main">
   <p:tag name="KSO_WM_UNIT_HIGHLIGHT" val="0"/>
   <p:tag name="KSO_WM_UNIT_COMPATIBLE" val="0"/>
   <p:tag name="KSO_WM_UNIT_DIAGRAM_ISNUMVISUAL" val="0"/>
@@ -5336,8 +5777,8 @@
 </p:tagLst>
 </file>
 
-<file path=ppt/tags/tag23.xml><?xml version="1.0" encoding="utf-8"?>
-<p:tagLst xmlns:p="http://schemas.openxmlformats.org/presentationml/2006/main">
+<file path=ppt/tags/tag29.xml><?xml version="1.0" encoding="utf-8"?>
+<p:tagLst xmlns:a="http://schemas.openxmlformats.org/drawingml/2006/main" xmlns:r="http://schemas.openxmlformats.org/officeDocument/2006/relationships" xmlns:p="http://schemas.openxmlformats.org/presentationml/2006/main">
   <p:tag name="KSO_WM_UNIT_HIGHLIGHT" val="0"/>
   <p:tag name="KSO_WM_UNIT_COMPATIBLE" val="0"/>
   <p:tag name="KSO_WM_UNIT_DIAGRAM_ISNUMVISUAL" val="0"/>
@@ -5349,8 +5790,23 @@
 </p:tagLst>
 </file>
 
-<file path=ppt/tags/tag24.xml><?xml version="1.0" encoding="utf-8"?>
-<p:tagLst xmlns:p="http://schemas.openxmlformats.org/presentationml/2006/main">
+<file path=ppt/tags/tag3.xml><?xml version="1.0" encoding="utf-8"?>
+<p:tagLst xmlns:a="http://schemas.openxmlformats.org/drawingml/2006/main" xmlns:r="http://schemas.openxmlformats.org/officeDocument/2006/relationships" xmlns:p="http://schemas.openxmlformats.org/presentationml/2006/main">
+  <p:tag name="KSO_WM_UNIT_HIGHLIGHT" val="0"/>
+  <p:tag name="KSO_WM_UNIT_COMPATIBLE" val="0"/>
+  <p:tag name="KSO_WM_UNIT_DIAGRAM_ISNUMVISUAL" val="0"/>
+  <p:tag name="KSO_WM_UNIT_DIAGRAM_ISREFERUNIT" val="0"/>
+  <p:tag name="KSO_WM_UNIT_ID" val="_0**"/>
+  <p:tag name="KSO_WM_UNIT_LAYERLEVEL" val="1"/>
+  <p:tag name="KSO_WM_TAG_VERSION" val="1.0"/>
+  <p:tag name="KSO_WM_BEAUTIFY_FLAG" val="#wm#"/>
+  <p:tag name="KSO_WM_TEMPLATE_CATEGORY" val="custom"/>
+  <p:tag name="KSO_WM_TEMPLATE_INDEX" val="20205081"/>
+</p:tagLst>
+</file>
+
+<file path=ppt/tags/tag30.xml><?xml version="1.0" encoding="utf-8"?>
+<p:tagLst xmlns:a="http://schemas.openxmlformats.org/drawingml/2006/main" xmlns:r="http://schemas.openxmlformats.org/officeDocument/2006/relationships" xmlns:p="http://schemas.openxmlformats.org/presentationml/2006/main">
   <p:tag name="KSO_WM_UNIT_HIGHLIGHT" val="0"/>
   <p:tag name="KSO_WM_UNIT_COMPATIBLE" val="0"/>
   <p:tag name="KSO_WM_UNIT_DIAGRAM_ISNUMVISUAL" val="0"/>
@@ -5362,8 +5818,8 @@
 </p:tagLst>
 </file>
 
-<file path=ppt/tags/tag25.xml><?xml version="1.0" encoding="utf-8"?>
-<p:tagLst xmlns:p="http://schemas.openxmlformats.org/presentationml/2006/main">
+<file path=ppt/tags/tag31.xml><?xml version="1.0" encoding="utf-8"?>
+<p:tagLst xmlns:a="http://schemas.openxmlformats.org/drawingml/2006/main" xmlns:r="http://schemas.openxmlformats.org/officeDocument/2006/relationships" xmlns:p="http://schemas.openxmlformats.org/presentationml/2006/main">
   <p:tag name="KSO_WM_UNIT_HIGHLIGHT" val="0"/>
   <p:tag name="KSO_WM_UNIT_COMPATIBLE" val="0"/>
   <p:tag name="KSO_WM_UNIT_DIAGRAM_ISNUMVISUAL" val="0"/>
@@ -5375,8 +5831,8 @@
 </p:tagLst>
 </file>
 
-<file path=ppt/tags/tag26.xml><?xml version="1.0" encoding="utf-8"?>
-<p:tagLst xmlns:p="http://schemas.openxmlformats.org/presentationml/2006/main">
+<file path=ppt/tags/tag32.xml><?xml version="1.0" encoding="utf-8"?>
+<p:tagLst xmlns:a="http://schemas.openxmlformats.org/drawingml/2006/main" xmlns:r="http://schemas.openxmlformats.org/officeDocument/2006/relationships" xmlns:p="http://schemas.openxmlformats.org/presentationml/2006/main">
   <p:tag name="KSO_WM_UNIT_HIGHLIGHT" val="0"/>
   <p:tag name="KSO_WM_UNIT_COMPATIBLE" val="0"/>
   <p:tag name="KSO_WM_UNIT_DIAGRAM_ISNUMVISUAL" val="0"/>
@@ -5388,8 +5844,8 @@
 </p:tagLst>
 </file>
 
-<file path=ppt/tags/tag27.xml><?xml version="1.0" encoding="utf-8"?>
-<p:tagLst xmlns:p="http://schemas.openxmlformats.org/presentationml/2006/main">
+<file path=ppt/tags/tag33.xml><?xml version="1.0" encoding="utf-8"?>
+<p:tagLst xmlns:a="http://schemas.openxmlformats.org/drawingml/2006/main" xmlns:r="http://schemas.openxmlformats.org/officeDocument/2006/relationships" xmlns:p="http://schemas.openxmlformats.org/presentationml/2006/main">
   <p:tag name="KSO_WM_UNIT_HIGHLIGHT" val="0"/>
   <p:tag name="KSO_WM_UNIT_COMPATIBLE" val="0"/>
   <p:tag name="KSO_WM_UNIT_DIAGRAM_ISNUMVISUAL" val="0"/>
@@ -5401,8 +5857,8 @@
 </p:tagLst>
 </file>
 
-<file path=ppt/tags/tag28.xml><?xml version="1.0" encoding="utf-8"?>
-<p:tagLst xmlns:p="http://schemas.openxmlformats.org/presentationml/2006/main">
+<file path=ppt/tags/tag34.xml><?xml version="1.0" encoding="utf-8"?>
+<p:tagLst xmlns:a="http://schemas.openxmlformats.org/drawingml/2006/main" xmlns:r="http://schemas.openxmlformats.org/officeDocument/2006/relationships" xmlns:p="http://schemas.openxmlformats.org/presentationml/2006/main">
   <p:tag name="KSO_WM_UNIT_HIGHLIGHT" val="0"/>
   <p:tag name="KSO_WM_UNIT_COMPATIBLE" val="0"/>
   <p:tag name="KSO_WM_UNIT_DIAGRAM_ISNUMVISUAL" val="0"/>
@@ -5414,8 +5870,8 @@
 </p:tagLst>
 </file>
 
-<file path=ppt/tags/tag29.xml><?xml version="1.0" encoding="utf-8"?>
-<p:tagLst xmlns:p="http://schemas.openxmlformats.org/presentationml/2006/main">
+<file path=ppt/tags/tag35.xml><?xml version="1.0" encoding="utf-8"?>
+<p:tagLst xmlns:a="http://schemas.openxmlformats.org/drawingml/2006/main" xmlns:r="http://schemas.openxmlformats.org/officeDocument/2006/relationships" xmlns:p="http://schemas.openxmlformats.org/presentationml/2006/main">
   <p:tag name="KSO_WM_UNIT_HIGHLIGHT" val="0"/>
   <p:tag name="KSO_WM_UNIT_COMPATIBLE" val="0"/>
   <p:tag name="KSO_WM_UNIT_DIAGRAM_ISNUMVISUAL" val="0"/>
@@ -5427,21 +5883,8 @@
 </p:tagLst>
 </file>
 
-<file path=ppt/tags/tag3.xml><?xml version="1.0" encoding="utf-8"?>
-<p:tagLst xmlns:p="http://schemas.openxmlformats.org/presentationml/2006/main">
-  <p:tag name="KSO_WM_UNIT_HIGHLIGHT" val="0"/>
-  <p:tag name="KSO_WM_UNIT_COMPATIBLE" val="0"/>
-  <p:tag name="KSO_WM_UNIT_DIAGRAM_ISNUMVISUAL" val="0"/>
-  <p:tag name="KSO_WM_UNIT_DIAGRAM_ISREFERUNIT" val="0"/>
-  <p:tag name="KSO_WM_UNIT_ID" val="_1**"/>
-  <p:tag name="KSO_WM_UNIT_LAYERLEVEL" val="1"/>
-  <p:tag name="KSO_WM_TAG_VERSION" val="1.0"/>
-  <p:tag name="KSO_WM_BEAUTIFY_FLAG" val="#wm#"/>
-</p:tagLst>
-</file>
-
-<file path=ppt/tags/tag30.xml><?xml version="1.0" encoding="utf-8"?>
-<p:tagLst xmlns:p="http://schemas.openxmlformats.org/presentationml/2006/main">
+<file path=ppt/tags/tag36.xml><?xml version="1.0" encoding="utf-8"?>
+<p:tagLst xmlns:a="http://schemas.openxmlformats.org/drawingml/2006/main" xmlns:r="http://schemas.openxmlformats.org/officeDocument/2006/relationships" xmlns:p="http://schemas.openxmlformats.org/presentationml/2006/main">
   <p:tag name="KSO_WM_UNIT_HIGHLIGHT" val="0"/>
   <p:tag name="KSO_WM_UNIT_COMPATIBLE" val="0"/>
   <p:tag name="KSO_WM_UNIT_DIAGRAM_ISNUMVISUAL" val="0"/>
@@ -5453,8 +5896,8 @@
 </p:tagLst>
 </file>
 
-<file path=ppt/tags/tag31.xml><?xml version="1.0" encoding="utf-8"?>
-<p:tagLst xmlns:p="http://schemas.openxmlformats.org/presentationml/2006/main">
+<file path=ppt/tags/tag37.xml><?xml version="1.0" encoding="utf-8"?>
+<p:tagLst xmlns:a="http://schemas.openxmlformats.org/drawingml/2006/main" xmlns:r="http://schemas.openxmlformats.org/officeDocument/2006/relationships" xmlns:p="http://schemas.openxmlformats.org/presentationml/2006/main">
   <p:tag name="KSO_WM_UNIT_HIGHLIGHT" val="0"/>
   <p:tag name="KSO_WM_UNIT_COMPATIBLE" val="0"/>
   <p:tag name="KSO_WM_UNIT_DIAGRAM_ISNUMVISUAL" val="0"/>
@@ -5466,8 +5909,8 @@
 </p:tagLst>
 </file>
 
-<file path=ppt/tags/tag32.xml><?xml version="1.0" encoding="utf-8"?>
-<p:tagLst xmlns:p="http://schemas.openxmlformats.org/presentationml/2006/main">
+<file path=ppt/tags/tag38.xml><?xml version="1.0" encoding="utf-8"?>
+<p:tagLst xmlns:a="http://schemas.openxmlformats.org/drawingml/2006/main" xmlns:r="http://schemas.openxmlformats.org/officeDocument/2006/relationships" xmlns:p="http://schemas.openxmlformats.org/presentationml/2006/main">
   <p:tag name="KSO_WM_UNIT_HIGHLIGHT" val="0"/>
   <p:tag name="KSO_WM_UNIT_COMPATIBLE" val="0"/>
   <p:tag name="KSO_WM_UNIT_DIAGRAM_ISNUMVISUAL" val="0"/>
@@ -5479,8 +5922,8 @@
 </p:tagLst>
 </file>
 
-<file path=ppt/tags/tag33.xml><?xml version="1.0" encoding="utf-8"?>
-<p:tagLst xmlns:p="http://schemas.openxmlformats.org/presentationml/2006/main">
+<file path=ppt/tags/tag39.xml><?xml version="1.0" encoding="utf-8"?>
+<p:tagLst xmlns:a="http://schemas.openxmlformats.org/drawingml/2006/main" xmlns:r="http://schemas.openxmlformats.org/officeDocument/2006/relationships" xmlns:p="http://schemas.openxmlformats.org/presentationml/2006/main">
   <p:tag name="KSO_WM_UNIT_HIGHLIGHT" val="0"/>
   <p:tag name="KSO_WM_UNIT_COMPATIBLE" val="0"/>
   <p:tag name="KSO_WM_UNIT_DIAGRAM_ISNUMVISUAL" val="0"/>
@@ -5492,8 +5935,21 @@
 </p:tagLst>
 </file>
 
-<file path=ppt/tags/tag34.xml><?xml version="1.0" encoding="utf-8"?>
-<p:tagLst xmlns:p="http://schemas.openxmlformats.org/presentationml/2006/main">
+<file path=ppt/tags/tag4.xml><?xml version="1.0" encoding="utf-8"?>
+<p:tagLst xmlns:a="http://schemas.openxmlformats.org/drawingml/2006/main" xmlns:r="http://schemas.openxmlformats.org/officeDocument/2006/relationships" xmlns:p="http://schemas.openxmlformats.org/presentationml/2006/main">
+  <p:tag name="KSO_WM_UNIT_HIGHLIGHT" val="0"/>
+  <p:tag name="KSO_WM_UNIT_COMPATIBLE" val="0"/>
+  <p:tag name="KSO_WM_UNIT_DIAGRAM_ISNUMVISUAL" val="0"/>
+  <p:tag name="KSO_WM_UNIT_DIAGRAM_ISREFERUNIT" val="0"/>
+  <p:tag name="KSO_WM_UNIT_ID" val="_0**"/>
+  <p:tag name="KSO_WM_UNIT_LAYERLEVEL" val="1"/>
+  <p:tag name="KSO_WM_TAG_VERSION" val="1.0"/>
+  <p:tag name="KSO_WM_BEAUTIFY_FLAG" val="#wm#"/>
+</p:tagLst>
+</file>
+
+<file path=ppt/tags/tag40.xml><?xml version="1.0" encoding="utf-8"?>
+<p:tagLst xmlns:a="http://schemas.openxmlformats.org/drawingml/2006/main" xmlns:r="http://schemas.openxmlformats.org/officeDocument/2006/relationships" xmlns:p="http://schemas.openxmlformats.org/presentationml/2006/main">
   <p:tag name="KSO_WM_UNIT_HIGHLIGHT" val="0"/>
   <p:tag name="KSO_WM_UNIT_COMPATIBLE" val="0"/>
   <p:tag name="KSO_WM_UNIT_DIAGRAM_ISNUMVISUAL" val="0"/>
@@ -5505,8 +5961,8 @@
 </p:tagLst>
 </file>
 
-<file path=ppt/tags/tag35.xml><?xml version="1.0" encoding="utf-8"?>
-<p:tagLst xmlns:p="http://schemas.openxmlformats.org/presentationml/2006/main">
+<file path=ppt/tags/tag41.xml><?xml version="1.0" encoding="utf-8"?>
+<p:tagLst xmlns:a="http://schemas.openxmlformats.org/drawingml/2006/main" xmlns:r="http://schemas.openxmlformats.org/officeDocument/2006/relationships" xmlns:p="http://schemas.openxmlformats.org/presentationml/2006/main">
   <p:tag name="KSO_WM_UNIT_HIGHLIGHT" val="0"/>
   <p:tag name="KSO_WM_UNIT_COMPATIBLE" val="0"/>
   <p:tag name="KSO_WM_UNIT_DIAGRAM_ISNUMVISUAL" val="0"/>
@@ -5518,8 +5974,8 @@
 </p:tagLst>
 </file>
 
-<file path=ppt/tags/tag36.xml><?xml version="1.0" encoding="utf-8"?>
-<p:tagLst xmlns:p="http://schemas.openxmlformats.org/presentationml/2006/main">
+<file path=ppt/tags/tag42.xml><?xml version="1.0" encoding="utf-8"?>
+<p:tagLst xmlns:a="http://schemas.openxmlformats.org/drawingml/2006/main" xmlns:r="http://schemas.openxmlformats.org/officeDocument/2006/relationships" xmlns:p="http://schemas.openxmlformats.org/presentationml/2006/main">
   <p:tag name="KSO_WM_UNIT_HIGHLIGHT" val="0"/>
   <p:tag name="KSO_WM_UNIT_COMPATIBLE" val="0"/>
   <p:tag name="KSO_WM_UNIT_DIAGRAM_ISNUMVISUAL" val="0"/>
@@ -5531,8 +5987,8 @@
 </p:tagLst>
 </file>
 
-<file path=ppt/tags/tag37.xml><?xml version="1.0" encoding="utf-8"?>
-<p:tagLst xmlns:p="http://schemas.openxmlformats.org/presentationml/2006/main">
+<file path=ppt/tags/tag43.xml><?xml version="1.0" encoding="utf-8"?>
+<p:tagLst xmlns:a="http://schemas.openxmlformats.org/drawingml/2006/main" xmlns:r="http://schemas.openxmlformats.org/officeDocument/2006/relationships" xmlns:p="http://schemas.openxmlformats.org/presentationml/2006/main">
   <p:tag name="KSO_WM_UNIT_HIGHLIGHT" val="0"/>
   <p:tag name="KSO_WM_UNIT_COMPATIBLE" val="0"/>
   <p:tag name="KSO_WM_UNIT_DIAGRAM_ISNUMVISUAL" val="0"/>
@@ -5544,8 +6000,8 @@
 </p:tagLst>
 </file>
 
-<file path=ppt/tags/tag38.xml><?xml version="1.0" encoding="utf-8"?>
-<p:tagLst xmlns:p="http://schemas.openxmlformats.org/presentationml/2006/main">
+<file path=ppt/tags/tag44.xml><?xml version="1.0" encoding="utf-8"?>
+<p:tagLst xmlns:a="http://schemas.openxmlformats.org/drawingml/2006/main" xmlns:r="http://schemas.openxmlformats.org/officeDocument/2006/relationships" xmlns:p="http://schemas.openxmlformats.org/presentationml/2006/main">
   <p:tag name="KSO_WM_UNIT_HIGHLIGHT" val="0"/>
   <p:tag name="KSO_WM_UNIT_COMPATIBLE" val="0"/>
   <p:tag name="KSO_WM_UNIT_DIAGRAM_ISNUMVISUAL" val="0"/>
@@ -5557,8 +6013,8 @@
 </p:tagLst>
 </file>
 
-<file path=ppt/tags/tag39.xml><?xml version="1.0" encoding="utf-8"?>
-<p:tagLst xmlns:p="http://schemas.openxmlformats.org/presentationml/2006/main">
+<file path=ppt/tags/tag45.xml><?xml version="1.0" encoding="utf-8"?>
+<p:tagLst xmlns:a="http://schemas.openxmlformats.org/drawingml/2006/main" xmlns:r="http://schemas.openxmlformats.org/officeDocument/2006/relationships" xmlns:p="http://schemas.openxmlformats.org/presentationml/2006/main">
   <p:tag name="KSO_WM_UNIT_HIGHLIGHT" val="0"/>
   <p:tag name="KSO_WM_UNIT_COMPATIBLE" val="0"/>
   <p:tag name="KSO_WM_UNIT_DIAGRAM_ISNUMVISUAL" val="0"/>
@@ -5570,21 +6026,8 @@
 </p:tagLst>
 </file>
 
-<file path=ppt/tags/tag4.xml><?xml version="1.0" encoding="utf-8"?>
-<p:tagLst xmlns:p="http://schemas.openxmlformats.org/presentationml/2006/main">
-  <p:tag name="KSO_WM_UNIT_HIGHLIGHT" val="0"/>
-  <p:tag name="KSO_WM_UNIT_COMPATIBLE" val="0"/>
-  <p:tag name="KSO_WM_UNIT_DIAGRAM_ISNUMVISUAL" val="0"/>
-  <p:tag name="KSO_WM_UNIT_DIAGRAM_ISREFERUNIT" val="0"/>
-  <p:tag name="KSO_WM_UNIT_ID" val="_1**"/>
-  <p:tag name="KSO_WM_UNIT_LAYERLEVEL" val="1"/>
-  <p:tag name="KSO_WM_TAG_VERSION" val="1.0"/>
-  <p:tag name="KSO_WM_BEAUTIFY_FLAG" val="#wm#"/>
-</p:tagLst>
-</file>
-
-<file path=ppt/tags/tag40.xml><?xml version="1.0" encoding="utf-8"?>
-<p:tagLst xmlns:p="http://schemas.openxmlformats.org/presentationml/2006/main">
+<file path=ppt/tags/tag46.xml><?xml version="1.0" encoding="utf-8"?>
+<p:tagLst xmlns:a="http://schemas.openxmlformats.org/drawingml/2006/main" xmlns:r="http://schemas.openxmlformats.org/officeDocument/2006/relationships" xmlns:p="http://schemas.openxmlformats.org/presentationml/2006/main">
   <p:tag name="KSO_WM_UNIT_HIGHLIGHT" val="0"/>
   <p:tag name="KSO_WM_UNIT_COMPATIBLE" val="0"/>
   <p:tag name="KSO_WM_UNIT_DIAGRAM_ISNUMVISUAL" val="0"/>
@@ -5596,8 +6039,8 @@
 </p:tagLst>
 </file>
 
-<file path=ppt/tags/tag41.xml><?xml version="1.0" encoding="utf-8"?>
-<p:tagLst xmlns:p="http://schemas.openxmlformats.org/presentationml/2006/main">
+<file path=ppt/tags/tag47.xml><?xml version="1.0" encoding="utf-8"?>
+<p:tagLst xmlns:a="http://schemas.openxmlformats.org/drawingml/2006/main" xmlns:r="http://schemas.openxmlformats.org/officeDocument/2006/relationships" xmlns:p="http://schemas.openxmlformats.org/presentationml/2006/main">
   <p:tag name="KSO_WM_UNIT_HIGHLIGHT" val="0"/>
   <p:tag name="KSO_WM_UNIT_COMPATIBLE" val="0"/>
   <p:tag name="KSO_WM_UNIT_DIAGRAM_ISNUMVISUAL" val="0"/>
@@ -5609,8 +6052,8 @@
 </p:tagLst>
 </file>
 
-<file path=ppt/tags/tag42.xml><?xml version="1.0" encoding="utf-8"?>
-<p:tagLst xmlns:p="http://schemas.openxmlformats.org/presentationml/2006/main">
+<file path=ppt/tags/tag48.xml><?xml version="1.0" encoding="utf-8"?>
+<p:tagLst xmlns:a="http://schemas.openxmlformats.org/drawingml/2006/main" xmlns:r="http://schemas.openxmlformats.org/officeDocument/2006/relationships" xmlns:p="http://schemas.openxmlformats.org/presentationml/2006/main">
   <p:tag name="KSO_WM_UNIT_HIGHLIGHT" val="0"/>
   <p:tag name="KSO_WM_UNIT_COMPATIBLE" val="0"/>
   <p:tag name="KSO_WM_UNIT_DIAGRAM_ISNUMVISUAL" val="0"/>
@@ -5622,8 +6065,8 @@
 </p:tagLst>
 </file>
 
-<file path=ppt/tags/tag43.xml><?xml version="1.0" encoding="utf-8"?>
-<p:tagLst xmlns:p="http://schemas.openxmlformats.org/presentationml/2006/main">
+<file path=ppt/tags/tag49.xml><?xml version="1.0" encoding="utf-8"?>
+<p:tagLst xmlns:a="http://schemas.openxmlformats.org/drawingml/2006/main" xmlns:r="http://schemas.openxmlformats.org/officeDocument/2006/relationships" xmlns:p="http://schemas.openxmlformats.org/presentationml/2006/main">
   <p:tag name="KSO_WM_UNIT_HIGHLIGHT" val="0"/>
   <p:tag name="KSO_WM_UNIT_COMPATIBLE" val="0"/>
   <p:tag name="KSO_WM_UNIT_DIAGRAM_ISNUMVISUAL" val="0"/>
@@ -5635,8 +6078,21 @@
 </p:tagLst>
 </file>
 
-<file path=ppt/tags/tag44.xml><?xml version="1.0" encoding="utf-8"?>
-<p:tagLst xmlns:p="http://schemas.openxmlformats.org/presentationml/2006/main">
+<file path=ppt/tags/tag5.xml><?xml version="1.0" encoding="utf-8"?>
+<p:tagLst xmlns:a="http://schemas.openxmlformats.org/drawingml/2006/main" xmlns:r="http://schemas.openxmlformats.org/officeDocument/2006/relationships" xmlns:p="http://schemas.openxmlformats.org/presentationml/2006/main">
+  <p:tag name="KSO_WM_UNIT_HIGHLIGHT" val="0"/>
+  <p:tag name="KSO_WM_UNIT_COMPATIBLE" val="0"/>
+  <p:tag name="KSO_WM_UNIT_DIAGRAM_ISNUMVISUAL" val="0"/>
+  <p:tag name="KSO_WM_UNIT_DIAGRAM_ISREFERUNIT" val="0"/>
+  <p:tag name="KSO_WM_UNIT_ID" val="_0**"/>
+  <p:tag name="KSO_WM_UNIT_LAYERLEVEL" val="1"/>
+  <p:tag name="KSO_WM_TAG_VERSION" val="1.0"/>
+  <p:tag name="KSO_WM_BEAUTIFY_FLAG" val="#wm#"/>
+</p:tagLst>
+</file>
+
+<file path=ppt/tags/tag50.xml><?xml version="1.0" encoding="utf-8"?>
+<p:tagLst xmlns:a="http://schemas.openxmlformats.org/drawingml/2006/main" xmlns:r="http://schemas.openxmlformats.org/officeDocument/2006/relationships" xmlns:p="http://schemas.openxmlformats.org/presentationml/2006/main">
   <p:tag name="KSO_WM_UNIT_HIGHLIGHT" val="0"/>
   <p:tag name="KSO_WM_UNIT_COMPATIBLE" val="0"/>
   <p:tag name="KSO_WM_UNIT_DIAGRAM_ISNUMVISUAL" val="0"/>
@@ -5648,8 +6104,8 @@
 </p:tagLst>
 </file>
 
-<file path=ppt/tags/tag45.xml><?xml version="1.0" encoding="utf-8"?>
-<p:tagLst xmlns:p="http://schemas.openxmlformats.org/presentationml/2006/main">
+<file path=ppt/tags/tag51.xml><?xml version="1.0" encoding="utf-8"?>
+<p:tagLst xmlns:a="http://schemas.openxmlformats.org/drawingml/2006/main" xmlns:r="http://schemas.openxmlformats.org/officeDocument/2006/relationships" xmlns:p="http://schemas.openxmlformats.org/presentationml/2006/main">
   <p:tag name="KSO_WM_UNIT_HIGHLIGHT" val="0"/>
   <p:tag name="KSO_WM_UNIT_COMPATIBLE" val="0"/>
   <p:tag name="KSO_WM_UNIT_DIAGRAM_ISNUMVISUAL" val="0"/>
@@ -5661,8 +6117,8 @@
 </p:tagLst>
 </file>
 
-<file path=ppt/tags/tag46.xml><?xml version="1.0" encoding="utf-8"?>
-<p:tagLst xmlns:p="http://schemas.openxmlformats.org/presentationml/2006/main">
+<file path=ppt/tags/tag52.xml><?xml version="1.0" encoding="utf-8"?>
+<p:tagLst xmlns:a="http://schemas.openxmlformats.org/drawingml/2006/main" xmlns:r="http://schemas.openxmlformats.org/officeDocument/2006/relationships" xmlns:p="http://schemas.openxmlformats.org/presentationml/2006/main">
   <p:tag name="KSO_WM_UNIT_HIGHLIGHT" val="0"/>
   <p:tag name="KSO_WM_UNIT_COMPATIBLE" val="0"/>
   <p:tag name="KSO_WM_UNIT_DIAGRAM_ISNUMVISUAL" val="0"/>
@@ -5674,8 +6130,8 @@
 </p:tagLst>
 </file>
 
-<file path=ppt/tags/tag47.xml><?xml version="1.0" encoding="utf-8"?>
-<p:tagLst xmlns:p="http://schemas.openxmlformats.org/presentationml/2006/main">
+<file path=ppt/tags/tag53.xml><?xml version="1.0" encoding="utf-8"?>
+<p:tagLst xmlns:a="http://schemas.openxmlformats.org/drawingml/2006/main" xmlns:r="http://schemas.openxmlformats.org/officeDocument/2006/relationships" xmlns:p="http://schemas.openxmlformats.org/presentationml/2006/main">
   <p:tag name="KSO_WM_UNIT_HIGHLIGHT" val="0"/>
   <p:tag name="KSO_WM_UNIT_COMPATIBLE" val="0"/>
   <p:tag name="KSO_WM_UNIT_DIAGRAM_ISNUMVISUAL" val="0"/>
@@ -5687,8 +6143,8 @@
 </p:tagLst>
 </file>
 
-<file path=ppt/tags/tag48.xml><?xml version="1.0" encoding="utf-8"?>
-<p:tagLst xmlns:p="http://schemas.openxmlformats.org/presentationml/2006/main">
+<file path=ppt/tags/tag54.xml><?xml version="1.0" encoding="utf-8"?>
+<p:tagLst xmlns:a="http://schemas.openxmlformats.org/drawingml/2006/main" xmlns:r="http://schemas.openxmlformats.org/officeDocument/2006/relationships" xmlns:p="http://schemas.openxmlformats.org/presentationml/2006/main">
   <p:tag name="KSO_WM_UNIT_HIGHLIGHT" val="0"/>
   <p:tag name="KSO_WM_UNIT_COMPATIBLE" val="0"/>
   <p:tag name="KSO_WM_UNIT_DIAGRAM_ISNUMVISUAL" val="0"/>
@@ -5700,8 +6156,8 @@
 </p:tagLst>
 </file>
 
-<file path=ppt/tags/tag49.xml><?xml version="1.0" encoding="utf-8"?>
-<p:tagLst xmlns:p="http://schemas.openxmlformats.org/presentationml/2006/main">
+<file path=ppt/tags/tag55.xml><?xml version="1.0" encoding="utf-8"?>
+<p:tagLst xmlns:a="http://schemas.openxmlformats.org/drawingml/2006/main" xmlns:r="http://schemas.openxmlformats.org/officeDocument/2006/relationships" xmlns:p="http://schemas.openxmlformats.org/presentationml/2006/main">
   <p:tag name="KSO_WM_UNIT_HIGHLIGHT" val="0"/>
   <p:tag name="KSO_WM_UNIT_COMPATIBLE" val="0"/>
   <p:tag name="KSO_WM_UNIT_DIAGRAM_ISNUMVISUAL" val="0"/>
@@ -5713,21 +6169,8 @@
 </p:tagLst>
 </file>
 
-<file path=ppt/tags/tag5.xml><?xml version="1.0" encoding="utf-8"?>
-<p:tagLst xmlns:p="http://schemas.openxmlformats.org/presentationml/2006/main">
-  <p:tag name="KSO_WM_UNIT_HIGHLIGHT" val="0"/>
-  <p:tag name="KSO_WM_UNIT_COMPATIBLE" val="0"/>
-  <p:tag name="KSO_WM_UNIT_DIAGRAM_ISNUMVISUAL" val="0"/>
-  <p:tag name="KSO_WM_UNIT_DIAGRAM_ISREFERUNIT" val="0"/>
-  <p:tag name="KSO_WM_UNIT_ID" val="_1**"/>
-  <p:tag name="KSO_WM_UNIT_LAYERLEVEL" val="1"/>
-  <p:tag name="KSO_WM_TAG_VERSION" val="1.0"/>
-  <p:tag name="KSO_WM_BEAUTIFY_FLAG" val="#wm#"/>
-</p:tagLst>
-</file>
-
-<file path=ppt/tags/tag50.xml><?xml version="1.0" encoding="utf-8"?>
-<p:tagLst xmlns:p="http://schemas.openxmlformats.org/presentationml/2006/main">
+<file path=ppt/tags/tag56.xml><?xml version="1.0" encoding="utf-8"?>
+<p:tagLst xmlns:a="http://schemas.openxmlformats.org/drawingml/2006/main" xmlns:r="http://schemas.openxmlformats.org/officeDocument/2006/relationships" xmlns:p="http://schemas.openxmlformats.org/presentationml/2006/main">
   <p:tag name="KSO_WM_UNIT_HIGHLIGHT" val="0"/>
   <p:tag name="KSO_WM_UNIT_COMPATIBLE" val="0"/>
   <p:tag name="KSO_WM_UNIT_DIAGRAM_ISNUMVISUAL" val="0"/>
@@ -5739,8 +6182,8 @@
 </p:tagLst>
 </file>
 
-<file path=ppt/tags/tag51.xml><?xml version="1.0" encoding="utf-8"?>
-<p:tagLst xmlns:p="http://schemas.openxmlformats.org/presentationml/2006/main">
+<file path=ppt/tags/tag57.xml><?xml version="1.0" encoding="utf-8"?>
+<p:tagLst xmlns:a="http://schemas.openxmlformats.org/drawingml/2006/main" xmlns:r="http://schemas.openxmlformats.org/officeDocument/2006/relationships" xmlns:p="http://schemas.openxmlformats.org/presentationml/2006/main">
   <p:tag name="KSO_WM_UNIT_HIGHLIGHT" val="0"/>
   <p:tag name="KSO_WM_UNIT_COMPATIBLE" val="0"/>
   <p:tag name="KSO_WM_UNIT_DIAGRAM_ISNUMVISUAL" val="0"/>
@@ -5752,8 +6195,8 @@
 </p:tagLst>
 </file>
 
-<file path=ppt/tags/tag52.xml><?xml version="1.0" encoding="utf-8"?>
-<p:tagLst xmlns:p="http://schemas.openxmlformats.org/presentationml/2006/main">
+<file path=ppt/tags/tag58.xml><?xml version="1.0" encoding="utf-8"?>
+<p:tagLst xmlns:a="http://schemas.openxmlformats.org/drawingml/2006/main" xmlns:r="http://schemas.openxmlformats.org/officeDocument/2006/relationships" xmlns:p="http://schemas.openxmlformats.org/presentationml/2006/main">
   <p:tag name="KSO_WM_UNIT_HIGHLIGHT" val="0"/>
   <p:tag name="KSO_WM_UNIT_COMPATIBLE" val="0"/>
   <p:tag name="KSO_WM_UNIT_DIAGRAM_ISNUMVISUAL" val="0"/>
@@ -5765,8 +6208,8 @@
 </p:tagLst>
 </file>
 
-<file path=ppt/tags/tag53.xml><?xml version="1.0" encoding="utf-8"?>
-<p:tagLst xmlns:p="http://schemas.openxmlformats.org/presentationml/2006/main">
+<file path=ppt/tags/tag59.xml><?xml version="1.0" encoding="utf-8"?>
+<p:tagLst xmlns:a="http://schemas.openxmlformats.org/drawingml/2006/main" xmlns:r="http://schemas.openxmlformats.org/officeDocument/2006/relationships" xmlns:p="http://schemas.openxmlformats.org/presentationml/2006/main">
   <p:tag name="KSO_WM_UNIT_HIGHLIGHT" val="0"/>
   <p:tag name="KSO_WM_UNIT_COMPATIBLE" val="0"/>
   <p:tag name="KSO_WM_UNIT_DIAGRAM_ISNUMVISUAL" val="0"/>
@@ -5778,8 +6221,21 @@
 </p:tagLst>
 </file>
 
-<file path=ppt/tags/tag54.xml><?xml version="1.0" encoding="utf-8"?>
-<p:tagLst xmlns:p="http://schemas.openxmlformats.org/presentationml/2006/main">
+<file path=ppt/tags/tag6.xml><?xml version="1.0" encoding="utf-8"?>
+<p:tagLst xmlns:a="http://schemas.openxmlformats.org/drawingml/2006/main" xmlns:r="http://schemas.openxmlformats.org/officeDocument/2006/relationships" xmlns:p="http://schemas.openxmlformats.org/presentationml/2006/main">
+  <p:tag name="KSO_WM_UNIT_HIGHLIGHT" val="0"/>
+  <p:tag name="KSO_WM_UNIT_COMPATIBLE" val="0"/>
+  <p:tag name="KSO_WM_UNIT_DIAGRAM_ISNUMVISUAL" val="0"/>
+  <p:tag name="KSO_WM_UNIT_DIAGRAM_ISREFERUNIT" val="0"/>
+  <p:tag name="KSO_WM_UNIT_ID" val="_0**"/>
+  <p:tag name="KSO_WM_UNIT_LAYERLEVEL" val="1"/>
+  <p:tag name="KSO_WM_TAG_VERSION" val="1.0"/>
+  <p:tag name="KSO_WM_BEAUTIFY_FLAG" val="#wm#"/>
+</p:tagLst>
+</file>
+
+<file path=ppt/tags/tag60.xml><?xml version="1.0" encoding="utf-8"?>
+<p:tagLst xmlns:a="http://schemas.openxmlformats.org/drawingml/2006/main" xmlns:r="http://schemas.openxmlformats.org/officeDocument/2006/relationships" xmlns:p="http://schemas.openxmlformats.org/presentationml/2006/main">
   <p:tag name="KSO_WM_UNIT_HIGHLIGHT" val="0"/>
   <p:tag name="KSO_WM_UNIT_COMPATIBLE" val="0"/>
   <p:tag name="KSO_WM_UNIT_DIAGRAM_ISNUMVISUAL" val="0"/>
@@ -5791,8 +6247,8 @@
 </p:tagLst>
 </file>
 
-<file path=ppt/tags/tag55.xml><?xml version="1.0" encoding="utf-8"?>
-<p:tagLst xmlns:p="http://schemas.openxmlformats.org/presentationml/2006/main">
+<file path=ppt/tags/tag61.xml><?xml version="1.0" encoding="utf-8"?>
+<p:tagLst xmlns:a="http://schemas.openxmlformats.org/drawingml/2006/main" xmlns:r="http://schemas.openxmlformats.org/officeDocument/2006/relationships" xmlns:p="http://schemas.openxmlformats.org/presentationml/2006/main">
   <p:tag name="KSO_WM_UNIT_HIGHLIGHT" val="0"/>
   <p:tag name="KSO_WM_UNIT_COMPATIBLE" val="0"/>
   <p:tag name="KSO_WM_UNIT_DIAGRAM_ISNUMVISUAL" val="0"/>
@@ -5804,8 +6260,8 @@
 </p:tagLst>
 </file>
 
-<file path=ppt/tags/tag56.xml><?xml version="1.0" encoding="utf-8"?>
-<p:tagLst xmlns:p="http://schemas.openxmlformats.org/presentationml/2006/main">
+<file path=ppt/tags/tag62.xml><?xml version="1.0" encoding="utf-8"?>
+<p:tagLst xmlns:a="http://schemas.openxmlformats.org/drawingml/2006/main" xmlns:r="http://schemas.openxmlformats.org/officeDocument/2006/relationships" xmlns:p="http://schemas.openxmlformats.org/presentationml/2006/main">
   <p:tag name="KSO_WM_UNIT_HIGHLIGHT" val="0"/>
   <p:tag name="KSO_WM_UNIT_COMPATIBLE" val="0"/>
   <p:tag name="KSO_WM_UNIT_DIAGRAM_ISNUMVISUAL" val="0"/>
@@ -5817,104 +6273,8 @@
 </p:tagLst>
 </file>
 
-<file path=ppt/tags/tag57.xml><?xml version="1.0" encoding="utf-8"?>
-<p:tagLst xmlns:p="http://schemas.openxmlformats.org/presentationml/2006/main">
-  <p:tag name="KSO_WM_UNIT_HIGHLIGHT" val="0"/>
-  <p:tag name="KSO_WM_UNIT_COMPATIBLE" val="0"/>
-  <p:tag name="KSO_WM_UNIT_DIAGRAM_ISNUMVISUAL" val="0"/>
-  <p:tag name="KSO_WM_UNIT_DIAGRAM_ISREFERUNIT" val="0"/>
-  <p:tag name="KSO_WM_UNIT_ID" val="_0**"/>
-  <p:tag name="KSO_WM_UNIT_LAYERLEVEL" val="1"/>
-  <p:tag name="KSO_WM_TAG_VERSION" val="1.0"/>
-  <p:tag name="KSO_WM_BEAUTIFY_FLAG" val="#wm#"/>
-  <p:tag name="KSO_WM_TEMPLATE_CATEGORY" val="custom"/>
-  <p:tag name="KSO_WM_TEMPLATE_INDEX" val="20205081"/>
-</p:tagLst>
-</file>
-
-<file path=ppt/tags/tag58.xml><?xml version="1.0" encoding="utf-8"?>
-<p:tagLst xmlns:p="http://schemas.openxmlformats.org/presentationml/2006/main">
-  <p:tag name="KSO_WM_UNIT_HIGHLIGHT" val="0"/>
-  <p:tag name="KSO_WM_UNIT_COMPATIBLE" val="0"/>
-  <p:tag name="KSO_WM_UNIT_DIAGRAM_ISNUMVISUAL" val="0"/>
-  <p:tag name="KSO_WM_UNIT_DIAGRAM_ISREFERUNIT" val="0"/>
-  <p:tag name="KSO_WM_UNIT_ID" val="_0**"/>
-  <p:tag name="KSO_WM_UNIT_LAYERLEVEL" val="1"/>
-  <p:tag name="KSO_WM_TAG_VERSION" val="1.0"/>
-  <p:tag name="KSO_WM_BEAUTIFY_FLAG" val="#wm#"/>
-  <p:tag name="KSO_WM_TEMPLATE_CATEGORY" val="custom"/>
-  <p:tag name="KSO_WM_TEMPLATE_INDEX" val="20205081"/>
-</p:tagLst>
-</file>
-
-<file path=ppt/tags/tag59.xml><?xml version="1.0" encoding="utf-8"?>
-<p:tagLst xmlns:p="http://schemas.openxmlformats.org/presentationml/2006/main">
-  <p:tag name="KSO_WM_UNIT_HIGHLIGHT" val="0"/>
-  <p:tag name="KSO_WM_UNIT_COMPATIBLE" val="0"/>
-  <p:tag name="KSO_WM_UNIT_DIAGRAM_ISNUMVISUAL" val="0"/>
-  <p:tag name="KSO_WM_UNIT_DIAGRAM_ISREFERUNIT" val="0"/>
-  <p:tag name="KSO_WM_UNIT_ID" val="_0**"/>
-  <p:tag name="KSO_WM_UNIT_LAYERLEVEL" val="1"/>
-  <p:tag name="KSO_WM_TAG_VERSION" val="1.0"/>
-  <p:tag name="KSO_WM_BEAUTIFY_FLAG" val="#wm#"/>
-</p:tagLst>
-</file>
-
-<file path=ppt/tags/tag6.xml><?xml version="1.0" encoding="utf-8"?>
-<p:tagLst xmlns:p="http://schemas.openxmlformats.org/presentationml/2006/main">
-  <p:tag name="KSO_WM_UNIT_HIGHLIGHT" val="0"/>
-  <p:tag name="KSO_WM_UNIT_COMPATIBLE" val="0"/>
-  <p:tag name="KSO_WM_UNIT_DIAGRAM_ISNUMVISUAL" val="0"/>
-  <p:tag name="KSO_WM_UNIT_DIAGRAM_ISREFERUNIT" val="0"/>
-  <p:tag name="KSO_WM_UNIT_ID" val="_2**"/>
-  <p:tag name="KSO_WM_UNIT_LAYERLEVEL" val="1"/>
-  <p:tag name="KSO_WM_TAG_VERSION" val="1.0"/>
-  <p:tag name="KSO_WM_BEAUTIFY_FLAG" val="#wm#"/>
-</p:tagLst>
-</file>
-
-<file path=ppt/tags/tag60.xml><?xml version="1.0" encoding="utf-8"?>
-<p:tagLst xmlns:p="http://schemas.openxmlformats.org/presentationml/2006/main">
-  <p:tag name="KSO_WM_UNIT_HIGHLIGHT" val="0"/>
-  <p:tag name="KSO_WM_UNIT_COMPATIBLE" val="0"/>
-  <p:tag name="KSO_WM_UNIT_DIAGRAM_ISNUMVISUAL" val="0"/>
-  <p:tag name="KSO_WM_UNIT_DIAGRAM_ISREFERUNIT" val="0"/>
-  <p:tag name="KSO_WM_UNIT_ID" val="_0**"/>
-  <p:tag name="KSO_WM_UNIT_LAYERLEVEL" val="1"/>
-  <p:tag name="KSO_WM_TAG_VERSION" val="1.0"/>
-  <p:tag name="KSO_WM_BEAUTIFY_FLAG" val="#wm#"/>
-</p:tagLst>
-</file>
-
-<file path=ppt/tags/tag61.xml><?xml version="1.0" encoding="utf-8"?>
-<p:tagLst xmlns:p="http://schemas.openxmlformats.org/presentationml/2006/main">
-  <p:tag name="KSO_WM_UNIT_HIGHLIGHT" val="0"/>
-  <p:tag name="KSO_WM_UNIT_COMPATIBLE" val="0"/>
-  <p:tag name="KSO_WM_UNIT_DIAGRAM_ISNUMVISUAL" val="0"/>
-  <p:tag name="KSO_WM_UNIT_DIAGRAM_ISREFERUNIT" val="0"/>
-  <p:tag name="KSO_WM_UNIT_ID" val="_0**"/>
-  <p:tag name="KSO_WM_UNIT_LAYERLEVEL" val="1"/>
-  <p:tag name="KSO_WM_TAG_VERSION" val="1.0"/>
-  <p:tag name="KSO_WM_BEAUTIFY_FLAG" val="#wm#"/>
-</p:tagLst>
-</file>
-
-<file path=ppt/tags/tag62.xml><?xml version="1.0" encoding="utf-8"?>
-<p:tagLst xmlns:p="http://schemas.openxmlformats.org/presentationml/2006/main">
-  <p:tag name="KSO_WM_TEMPLATE_THUMBS_INDEX" val="1、4、7、12、13、14、15、16、17、18、20、24、25、28、33、36、40、43、44"/>
-  <p:tag name="KSO_WM_TEMPLATE_SUBCATEGORY" val="19"/>
-  <p:tag name="KSO_WM_TAG_VERSION" val="1.0"/>
-  <p:tag name="KSO_WM_BEAUTIFY_FLAG" val="#wm#"/>
-  <p:tag name="KSO_WM_TEMPLATE_CATEGORY" val="custom"/>
-  <p:tag name="KSO_WM_TEMPLATE_INDEX" val="20205081"/>
-  <p:tag name="KSO_WM_TEMPLATE_MASTER_TYPE" val="0"/>
-  <p:tag name="KSO_WM_TEMPLATE_COLOR_TYPE" val="1"/>
-  <p:tag name="KSO_WM_UNIT_SHOW_EDIT_AREA_INDICATION" val="1"/>
-</p:tagLst>
-</file>
-
 <file path=ppt/tags/tag63.xml><?xml version="1.0" encoding="utf-8"?>
-<p:tagLst xmlns:p="http://schemas.openxmlformats.org/presentationml/2006/main">
+<p:tagLst xmlns:a="http://schemas.openxmlformats.org/drawingml/2006/main" xmlns:r="http://schemas.openxmlformats.org/officeDocument/2006/relationships" xmlns:p="http://schemas.openxmlformats.org/presentationml/2006/main">
   <p:tag name="KSO_WM_SLIDE_ID" val="custom20205081_1"/>
   <p:tag name="KSO_WM_TEMPLATE_SUBCATEGORY" val="19"/>
   <p:tag name="KSO_WM_TEMPLATE_MASTER_TYPE" val="0"/>
@@ -5935,7 +6295,7 @@
 </file>
 
 <file path=ppt/tags/tag64.xml><?xml version="1.0" encoding="utf-8"?>
-<p:tagLst xmlns:p="http://schemas.openxmlformats.org/presentationml/2006/main">
+<p:tagLst xmlns:a="http://schemas.openxmlformats.org/drawingml/2006/main" xmlns:r="http://schemas.openxmlformats.org/officeDocument/2006/relationships" xmlns:p="http://schemas.openxmlformats.org/presentationml/2006/main">
   <p:tag name="KSO_WM_SLIDE_ID" val="custom20205081_1"/>
   <p:tag name="KSO_WM_TEMPLATE_SUBCATEGORY" val="19"/>
   <p:tag name="KSO_WM_TEMPLATE_MASTER_TYPE" val="0"/>
@@ -5956,7 +6316,7 @@
 </file>
 
 <file path=ppt/tags/tag65.xml><?xml version="1.0" encoding="utf-8"?>
-<p:tagLst xmlns:p="http://schemas.openxmlformats.org/presentationml/2006/main">
+<p:tagLst xmlns:a="http://schemas.openxmlformats.org/drawingml/2006/main" xmlns:r="http://schemas.openxmlformats.org/officeDocument/2006/relationships" xmlns:p="http://schemas.openxmlformats.org/presentationml/2006/main">
   <p:tag name="KSO_WM_BEAUTIFY_FLAG" val="#wm#"/>
   <p:tag name="KSO_WM_TEMPLATE_CATEGORY" val="custom"/>
   <p:tag name="KSO_WM_TEMPLATE_INDEX" val="20205081"/>
@@ -5964,7 +6324,7 @@
 </file>
 
 <file path=ppt/tags/tag66.xml><?xml version="1.0" encoding="utf-8"?>
-<p:tagLst xmlns:p="http://schemas.openxmlformats.org/presentationml/2006/main">
+<p:tagLst xmlns:a="http://schemas.openxmlformats.org/drawingml/2006/main" xmlns:r="http://schemas.openxmlformats.org/officeDocument/2006/relationships" xmlns:p="http://schemas.openxmlformats.org/presentationml/2006/main">
   <p:tag name="KSO_WM_BEAUTIFY_FLAG" val="#wm#"/>
   <p:tag name="KSO_WM_TEMPLATE_CATEGORY" val="custom"/>
   <p:tag name="KSO_WM_TEMPLATE_INDEX" val="20205081"/>
@@ -5972,7 +6332,7 @@
 </file>
 
 <file path=ppt/tags/tag67.xml><?xml version="1.0" encoding="utf-8"?>
-<p:tagLst xmlns:p="http://schemas.openxmlformats.org/presentationml/2006/main">
+<p:tagLst xmlns:a="http://schemas.openxmlformats.org/drawingml/2006/main" xmlns:r="http://schemas.openxmlformats.org/officeDocument/2006/relationships" xmlns:p="http://schemas.openxmlformats.org/presentationml/2006/main">
   <p:tag name="KSO_WM_BEAUTIFY_FLAG" val="#wm#"/>
   <p:tag name="KSO_WM_TEMPLATE_CATEGORY" val="custom"/>
   <p:tag name="KSO_WM_TEMPLATE_INDEX" val="20205081"/>
@@ -5980,7 +6340,7 @@
 </file>
 
 <file path=ppt/tags/tag68.xml><?xml version="1.0" encoding="utf-8"?>
-<p:tagLst xmlns:p="http://schemas.openxmlformats.org/presentationml/2006/main">
+<p:tagLst xmlns:a="http://schemas.openxmlformats.org/drawingml/2006/main" xmlns:r="http://schemas.openxmlformats.org/officeDocument/2006/relationships" xmlns:p="http://schemas.openxmlformats.org/presentationml/2006/main">
   <p:tag name="KSO_WM_BEAUTIFY_FLAG" val="#wm#"/>
   <p:tag name="KSO_WM_TEMPLATE_CATEGORY" val="custom"/>
   <p:tag name="KSO_WM_TEMPLATE_INDEX" val="20205081"/>
@@ -5988,7 +6348,7 @@
 </file>
 
 <file path=ppt/tags/tag69.xml><?xml version="1.0" encoding="utf-8"?>
-<p:tagLst xmlns:p="http://schemas.openxmlformats.org/presentationml/2006/main">
+<p:tagLst xmlns:a="http://schemas.openxmlformats.org/drawingml/2006/main" xmlns:r="http://schemas.openxmlformats.org/officeDocument/2006/relationships" xmlns:p="http://schemas.openxmlformats.org/presentationml/2006/main">
   <p:tag name="KSO_WM_BEAUTIFY_FLAG" val="#wm#"/>
   <p:tag name="KSO_WM_TEMPLATE_CATEGORY" val="custom"/>
   <p:tag name="KSO_WM_TEMPLATE_INDEX" val="20205081"/>
@@ -5996,7 +6356,60 @@
 </file>
 
 <file path=ppt/tags/tag7.xml><?xml version="1.0" encoding="utf-8"?>
-<p:tagLst xmlns:p="http://schemas.openxmlformats.org/presentationml/2006/main">
+<p:tagLst xmlns:a="http://schemas.openxmlformats.org/drawingml/2006/main" xmlns:r="http://schemas.openxmlformats.org/officeDocument/2006/relationships" xmlns:p="http://schemas.openxmlformats.org/presentationml/2006/main">
+  <p:tag name="KSO_WM_UNIT_HIGHLIGHT" val="0"/>
+  <p:tag name="KSO_WM_UNIT_COMPATIBLE" val="0"/>
+  <p:tag name="KSO_WM_UNIT_DIAGRAM_ISNUMVISUAL" val="0"/>
+  <p:tag name="KSO_WM_UNIT_DIAGRAM_ISREFERUNIT" val="0"/>
+  <p:tag name="KSO_WM_UNIT_ID" val="_1**"/>
+  <p:tag name="KSO_WM_UNIT_LAYERLEVEL" val="1"/>
+  <p:tag name="KSO_WM_TAG_VERSION" val="1.0"/>
+  <p:tag name="KSO_WM_BEAUTIFY_FLAG" val="#wm#"/>
+</p:tagLst>
+</file>
+
+<file path=ppt/tags/tag70.xml><?xml version="1.0" encoding="utf-8"?>
+<p:tagLst xmlns:a="http://schemas.openxmlformats.org/drawingml/2006/main" xmlns:r="http://schemas.openxmlformats.org/officeDocument/2006/relationships" xmlns:p="http://schemas.openxmlformats.org/presentationml/2006/main">
+  <p:tag name="KSO_WM_BEAUTIFY_FLAG" val="#wm#"/>
+  <p:tag name="KSO_WM_TEMPLATE_CATEGORY" val="custom"/>
+  <p:tag name="KSO_WM_TEMPLATE_INDEX" val="20205081"/>
+</p:tagLst>
+</file>
+
+<file path=ppt/tags/tag71.xml><?xml version="1.0" encoding="utf-8"?>
+<p:tagLst xmlns:a="http://schemas.openxmlformats.org/drawingml/2006/main" xmlns:r="http://schemas.openxmlformats.org/officeDocument/2006/relationships" xmlns:p="http://schemas.openxmlformats.org/presentationml/2006/main">
+  <p:tag name="KSO_WM_BEAUTIFY_FLAG" val="#wm#"/>
+  <p:tag name="KSO_WM_TEMPLATE_CATEGORY" val="custom"/>
+  <p:tag name="KSO_WM_TEMPLATE_INDEX" val="20205081"/>
+</p:tagLst>
+</file>
+
+<file path=ppt/tags/tag72.xml><?xml version="1.0" encoding="utf-8"?>
+<p:tagLst xmlns:a="http://schemas.openxmlformats.org/drawingml/2006/main" xmlns:r="http://schemas.openxmlformats.org/officeDocument/2006/relationships" xmlns:p="http://schemas.openxmlformats.org/presentationml/2006/main">
+  <p:tag name="KSO_WM_BEAUTIFY_FLAG" val="#wm#"/>
+  <p:tag name="KSO_WM_TEMPLATE_CATEGORY" val="custom"/>
+  <p:tag name="KSO_WM_TEMPLATE_INDEX" val="20205081"/>
+</p:tagLst>
+</file>
+
+<file path=ppt/tags/tag73.xml><?xml version="1.0" encoding="utf-8"?>
+<p:tagLst xmlns:a="http://schemas.openxmlformats.org/drawingml/2006/main" xmlns:r="http://schemas.openxmlformats.org/officeDocument/2006/relationships" xmlns:p="http://schemas.openxmlformats.org/presentationml/2006/main">
+  <p:tag name="KSO_WM_BEAUTIFY_FLAG" val="#wm#"/>
+  <p:tag name="KSO_WM_TEMPLATE_CATEGORY" val="custom"/>
+  <p:tag name="KSO_WM_TEMPLATE_INDEX" val="20205081"/>
+</p:tagLst>
+</file>
+
+<file path=ppt/tags/tag74.xml><?xml version="1.0" encoding="utf-8"?>
+<p:tagLst xmlns:a="http://schemas.openxmlformats.org/drawingml/2006/main" xmlns:r="http://schemas.openxmlformats.org/officeDocument/2006/relationships" xmlns:p="http://schemas.openxmlformats.org/presentationml/2006/main">
+  <p:tag name="KSO_WM_BEAUTIFY_FLAG" val="#wm#"/>
+  <p:tag name="KSO_WM_TEMPLATE_CATEGORY" val="custom"/>
+  <p:tag name="KSO_WM_TEMPLATE_INDEX" val="20205081"/>
+</p:tagLst>
+</file>
+
+<file path=ppt/tags/tag75.xml><?xml version="1.0" encoding="utf-8"?>
+<p:tagLst xmlns:a="http://schemas.openxmlformats.org/drawingml/2006/main" xmlns:r="http://schemas.openxmlformats.org/officeDocument/2006/relationships" xmlns:p="http://schemas.openxmlformats.org/presentationml/2006/main">
   <p:tag name="KSO_WM_UNIT_HIGHLIGHT" val="0"/>
   <p:tag name="KSO_WM_UNIT_COMPATIBLE" val="0"/>
   <p:tag name="KSO_WM_UNIT_DIAGRAM_ISNUMVISUAL" val="0"/>
@@ -6008,71 +6421,26 @@
 </p:tagLst>
 </file>
 
-<file path=ppt/tags/tag70.xml><?xml version="1.0" encoding="utf-8"?>
-<p:tagLst xmlns:p="http://schemas.openxmlformats.org/presentationml/2006/main">
-  <p:tag name="KSO_WM_BEAUTIFY_FLAG" val="#wm#"/>
-  <p:tag name="KSO_WM_TEMPLATE_CATEGORY" val="custom"/>
-  <p:tag name="KSO_WM_TEMPLATE_INDEX" val="20205081"/>
-</p:tagLst>
-</file>
-
-<file path=ppt/tags/tag71.xml><?xml version="1.0" encoding="utf-8"?>
-<p:tagLst xmlns:p="http://schemas.openxmlformats.org/presentationml/2006/main">
-  <p:tag name="KSO_WM_BEAUTIFY_FLAG" val="#wm#"/>
-  <p:tag name="KSO_WM_TEMPLATE_CATEGORY" val="custom"/>
-  <p:tag name="KSO_WM_TEMPLATE_INDEX" val="20205081"/>
-</p:tagLst>
-</file>
-
-<file path=ppt/tags/tag72.xml><?xml version="1.0" encoding="utf-8"?>
-<p:tagLst xmlns:p="http://schemas.openxmlformats.org/presentationml/2006/main">
-  <p:tag name="KSO_WM_BEAUTIFY_FLAG" val="#wm#"/>
-  <p:tag name="KSO_WM_TEMPLATE_CATEGORY" val="custom"/>
-  <p:tag name="KSO_WM_TEMPLATE_INDEX" val="20205081"/>
-</p:tagLst>
-</file>
-
-<file path=ppt/tags/tag73.xml><?xml version="1.0" encoding="utf-8"?>
-<p:tagLst xmlns:p="http://schemas.openxmlformats.org/presentationml/2006/main">
+<file path=ppt/tags/tag8.xml><?xml version="1.0" encoding="utf-8"?>
+<p:tagLst xmlns:a="http://schemas.openxmlformats.org/drawingml/2006/main" xmlns:r="http://schemas.openxmlformats.org/officeDocument/2006/relationships" xmlns:p="http://schemas.openxmlformats.org/presentationml/2006/main">
   <p:tag name="KSO_WM_UNIT_HIGHLIGHT" val="0"/>
   <p:tag name="KSO_WM_UNIT_COMPATIBLE" val="0"/>
   <p:tag name="KSO_WM_UNIT_DIAGRAM_ISNUMVISUAL" val="0"/>
   <p:tag name="KSO_WM_UNIT_DIAGRAM_ISREFERUNIT" val="0"/>
-  <p:tag name="KSO_WM_UNIT_ID" val="_2**"/>
+  <p:tag name="KSO_WM_UNIT_ID" val="_1**"/>
   <p:tag name="KSO_WM_UNIT_LAYERLEVEL" val="1"/>
   <p:tag name="KSO_WM_TAG_VERSION" val="1.0"/>
   <p:tag name="KSO_WM_BEAUTIFY_FLAG" val="#wm#"/>
 </p:tagLst>
 </file>
 
-<file path=ppt/tags/tag74.xml><?xml version="1.0" encoding="utf-8"?>
-<p:tagLst xmlns:p="http://schemas.openxmlformats.org/presentationml/2006/main">
-  <p:tag name="KSO_WM_BEAUTIFY_FLAG" val="#wm#"/>
-  <p:tag name="KSO_WM_TEMPLATE_CATEGORY" val="custom"/>
-  <p:tag name="KSO_WM_TEMPLATE_INDEX" val="20205081"/>
-</p:tagLst>
-</file>
-
-<file path=ppt/tags/tag8.xml><?xml version="1.0" encoding="utf-8"?>
-<p:tagLst xmlns:p="http://schemas.openxmlformats.org/presentationml/2006/main">
+<file path=ppt/tags/tag9.xml><?xml version="1.0" encoding="utf-8"?>
+<p:tagLst xmlns:a="http://schemas.openxmlformats.org/drawingml/2006/main" xmlns:r="http://schemas.openxmlformats.org/officeDocument/2006/relationships" xmlns:p="http://schemas.openxmlformats.org/presentationml/2006/main">
   <p:tag name="KSO_WM_UNIT_HIGHLIGHT" val="0"/>
   <p:tag name="KSO_WM_UNIT_COMPATIBLE" val="0"/>
   <p:tag name="KSO_WM_UNIT_DIAGRAM_ISNUMVISUAL" val="0"/>
   <p:tag name="KSO_WM_UNIT_DIAGRAM_ISREFERUNIT" val="0"/>
-  <p:tag name="KSO_WM_UNIT_ID" val="_2**"/>
-  <p:tag name="KSO_WM_UNIT_LAYERLEVEL" val="1"/>
-  <p:tag name="KSO_WM_TAG_VERSION" val="1.0"/>
-  <p:tag name="KSO_WM_BEAUTIFY_FLAG" val="#wm#"/>
-</p:tagLst>
-</file>
-
-<file path=ppt/tags/tag9.xml><?xml version="1.0" encoding="utf-8"?>
-<p:tagLst xmlns:p="http://schemas.openxmlformats.org/presentationml/2006/main">
-  <p:tag name="KSO_WM_UNIT_HIGHLIGHT" val="0"/>
-  <p:tag name="KSO_WM_UNIT_COMPATIBLE" val="0"/>
-  <p:tag name="KSO_WM_UNIT_DIAGRAM_ISNUMVISUAL" val="0"/>
-  <p:tag name="KSO_WM_UNIT_DIAGRAM_ISREFERUNIT" val="0"/>
-  <p:tag name="KSO_WM_UNIT_ID" val="_2**"/>
+  <p:tag name="KSO_WM_UNIT_ID" val="_1**"/>
   <p:tag name="KSO_WM_UNIT_LAYERLEVEL" val="1"/>
   <p:tag name="KSO_WM_TAG_VERSION" val="1.0"/>
   <p:tag name="KSO_WM_BEAUTIFY_FLAG" val="#wm#"/>
@@ -6262,6 +6630,8 @@
       </a:bgFillStyleLst>
     </a:fmtScheme>
   </a:themeElements>
+  <a:objectDefaults/>
+  <a:extraClrSchemeLst/>
   <a:extLst>
     <a:ext uri="{05A4C25C-085E-4340-85A3-A5531E510DB2}">
       <thm15:themeFamily xmlns:thm15="http://schemas.microsoft.com/office/thememl/2012/main" name="Office Theme" id="{62F939B6-93AF-4DB8-9C6B-D6C7DFDC589F}" vid="{4A3C46E8-61CC-4603-A589-7422A47A8E4A}"/>

</xml_diff>